<commit_message>
Restyle Riggs deck: themed prism backgrounds, Persian fonts, RTL layout
Co-Authored-By: Claude Sonnet 5.5 <noreply@anthropic.com>
Claude-Session: https://claude.ai/code/session_01SLUt5mXodhduysLfzMNqCj
</commit_message>
<xml_diff>
--- a/riggs-bureaucracy.pptx
+++ b/riggs-bureaucracy.pptx
@@ -1558,9 +1558,16 @@
   <p:cSld name="DARK">
     <p:bg>
       <p:bgPr>
-        <a:solidFill>
-          <a:schemeClr val="tx2"/>
-        </a:solidFill>
+        <a:blipFill dpi="0" rotWithShape="1">
+          <a:blip r:embed="rId1">
+            <a:lum/>
+          </a:blip>
+          <a:srcRect/>
+          <a:stretch>
+            <a:fillRect/>
+          </a:stretch>
+        </a:blipFill>
+        <a:effectLst/>
       </p:bgPr>
     </p:bg>
     <p:spTree>
@@ -1590,9 +1597,16 @@
   <p:cSld name="LIGHT">
     <p:bg>
       <p:bgPr>
-        <a:solidFill>
-          <a:schemeClr val="bg1"/>
-        </a:solidFill>
+        <a:blipFill dpi="0" rotWithShape="1">
+          <a:blip r:embed="rId1">
+            <a:lum/>
+          </a:blip>
+          <a:srcRect/>
+          <a:stretch>
+            <a:fillRect/>
+          </a:stretch>
+        </a:blipFill>
+        <a:effectLst/>
       </p:bgPr>
     </p:bg>
     <p:spTree>
@@ -2028,14 +2042,17 @@
               <a:buNone/>
             </a:pPr>
             <a:r>
-              <a:rPr lang="en-US" sz="4000" b="1" dirty="0">
+              <a:rPr lang="en-US" sz="4200" dirty="0">
                 <a:solidFill>
                   <a:schemeClr val="bg1"/>
                 </a:solidFill>
+                <a:latin typeface="B Titr" pitchFamily="34" charset="0"/>
+                <a:ea typeface="B Titr" pitchFamily="34" charset="-122"/>
+                <a:cs typeface="B Titr" pitchFamily="34" charset="-120"/>
               </a:rPr>
               <a:t>بوروکراسی و مدل‌های اداره امور عمومی</a:t>
             </a:r>
-            <a:endParaRPr lang="en-US" sz="4000" dirty="0"/>
+            <a:endParaRPr lang="en-US" sz="4200" dirty="0"/>
           </a:p>
         </p:txBody>
       </p:sp>
@@ -2064,14 +2081,17 @@
               <a:buNone/>
             </a:pPr>
             <a:r>
-              <a:rPr lang="en-US" sz="1800" dirty="0">
+              <a:rPr lang="en-US" sz="2000" dirty="0">
                 <a:solidFill>
                   <a:srgbClr val="CFE3E1"/>
                 </a:solidFill>
+                <a:latin typeface="B Nazanin" pitchFamily="34" charset="0"/>
+                <a:ea typeface="B Nazanin" pitchFamily="34" charset="-122"/>
+                <a:cs typeface="B Nazanin" pitchFamily="34" charset="-120"/>
               </a:rPr>
               <a:t>برگرفته از کتاب «چارچوبی برای مطالعات تطبیقی» (فصل ۲) — فرد ریگز</a:t>
             </a:r>
-            <a:endParaRPr lang="en-US" sz="1800" dirty="0"/>
+            <a:endParaRPr lang="en-US" sz="2000" dirty="0"/>
           </a:p>
         </p:txBody>
       </p:sp>
@@ -2100,14 +2120,17 @@
               <a:buNone/>
             </a:pPr>
             <a:r>
-              <a:rPr lang="en-US" sz="1600" b="1" dirty="0">
+              <a:rPr lang="en-US" sz="1800" b="1" dirty="0">
                 <a:solidFill>
                   <a:srgbClr val="F2B661"/>
                 </a:solidFill>
+                <a:latin typeface="B Nazanin" pitchFamily="34" charset="0"/>
+                <a:ea typeface="B Nazanin" pitchFamily="34" charset="-122"/>
+                <a:cs typeface="B Nazanin" pitchFamily="34" charset="-120"/>
               </a:rPr>
               <a:t>ارائه‌دهنده: حمیده رزدان</a:t>
             </a:r>
-            <a:endParaRPr lang="en-US" sz="1600" dirty="0"/>
+            <a:endParaRPr lang="en-US" sz="1800" dirty="0"/>
           </a:p>
         </p:txBody>
       </p:sp>
@@ -2163,14 +2186,17 @@
               <a:buNone/>
             </a:pPr>
             <a:r>
-              <a:rPr lang="en-US" sz="3200" b="1" dirty="0">
+              <a:rPr lang="en-US" sz="3400" dirty="0">
                 <a:solidFill>
                   <a:schemeClr val="accent1"/>
                 </a:solidFill>
+                <a:latin typeface="B Titr" pitchFamily="34" charset="0"/>
+                <a:ea typeface="B Titr" pitchFamily="34" charset="-122"/>
+                <a:cs typeface="B Titr" pitchFamily="34" charset="-120"/>
               </a:rPr>
               <a:t>انواع نظام‌های اداری بر اساس «ریگز»</a:t>
             </a:r>
-            <a:endParaRPr lang="en-US" sz="3200" dirty="0"/>
+            <a:endParaRPr lang="en-US" sz="3400" dirty="0"/>
           </a:p>
         </p:txBody>
       </p:sp>
@@ -2183,11 +2209,11 @@
         <p:spPr>
           <a:xfrm>
             <a:off x="4709160" y="1234440"/>
-            <a:ext cx="3977640" cy="2606040"/>
+            <a:ext cx="3977640" cy="2743200"/>
           </a:xfrm>
           <a:prstGeom prst="roundRect">
             <a:avLst>
-              <a:gd name="adj" fmla="val 3509"/>
+              <a:gd name="adj" fmla="val 3333"/>
             </a:avLst>
           </a:prstGeom>
           <a:solidFill>
@@ -2209,8 +2235,8 @@
         </p:nvSpPr>
         <p:spPr>
           <a:xfrm>
-            <a:off x="4846320" y="1344168"/>
-            <a:ext cx="3703320" cy="411480"/>
+            <a:off x="4846320" y="1325880"/>
+            <a:ext cx="3703320" cy="640080"/>
           </a:xfrm>
           <a:prstGeom prst="rect">
             <a:avLst/>
@@ -2226,14 +2252,17 @@
               <a:buNone/>
             </a:pPr>
             <a:r>
-              <a:rPr lang="en-US" sz="1600" b="1" dirty="0">
+              <a:rPr lang="en-US" sz="1700" b="1" dirty="0">
                 <a:solidFill>
                   <a:schemeClr val="tx2"/>
                 </a:solidFill>
+                <a:latin typeface="B Nazanin" pitchFamily="34" charset="0"/>
+                <a:ea typeface="B Nazanin" pitchFamily="34" charset="-122"/>
+                <a:cs typeface="B Nazanin" pitchFamily="34" charset="-120"/>
               </a:rPr>
               <a:t>معیار طبقه‌بندی</a:t>
             </a:r>
-            <a:endParaRPr lang="en-US" sz="1600" dirty="0"/>
+            <a:endParaRPr lang="en-US" sz="1700" dirty="0"/>
           </a:p>
         </p:txBody>
       </p:sp>
@@ -2245,8 +2274,8 @@
         </p:nvSpPr>
         <p:spPr>
           <a:xfrm>
-            <a:off x="4846320" y="1801368"/>
-            <a:ext cx="3703320" cy="1920240"/>
+            <a:off x="4846320" y="2011680"/>
+            <a:ext cx="3703320" cy="1874520"/>
           </a:xfrm>
           <a:prstGeom prst="rect">
             <a:avLst/>
@@ -2266,14 +2295,17 @@
               <a:buChar char="•"/>
             </a:pPr>
             <a:r>
-              <a:rPr lang="en-US" sz="1400" dirty="0">
+              <a:rPr lang="en-US" sz="1500" dirty="0">
                 <a:solidFill>
                   <a:schemeClr val="tx1"/>
                 </a:solidFill>
+                <a:latin typeface="B Nazanin" pitchFamily="34" charset="0"/>
+                <a:ea typeface="B Nazanin" pitchFamily="34" charset="-122"/>
+                <a:cs typeface="B Nazanin" pitchFamily="34" charset="-120"/>
               </a:rPr>
               <a:t>رابطه سیستم اداری با سیستم سیاسی، اقتصادی و اجتماعی</a:t>
             </a:r>
-            <a:endParaRPr lang="en-US" sz="1400" dirty="0"/>
+            <a:endParaRPr lang="en-US" sz="1500" dirty="0"/>
           </a:p>
         </p:txBody>
       </p:sp>
@@ -2286,11 +2318,11 @@
         <p:spPr>
           <a:xfrm>
             <a:off x="457200" y="1234440"/>
-            <a:ext cx="3977640" cy="2606040"/>
+            <a:ext cx="3977640" cy="2743200"/>
           </a:xfrm>
           <a:prstGeom prst="roundRect">
             <a:avLst>
-              <a:gd name="adj" fmla="val 3509"/>
+              <a:gd name="adj" fmla="val 3333"/>
             </a:avLst>
           </a:prstGeom>
           <a:solidFill>
@@ -2312,8 +2344,8 @@
         </p:nvSpPr>
         <p:spPr>
           <a:xfrm>
-            <a:off x="594360" y="1344168"/>
-            <a:ext cx="3703320" cy="411480"/>
+            <a:off x="594360" y="1325880"/>
+            <a:ext cx="3703320" cy="640080"/>
           </a:xfrm>
           <a:prstGeom prst="rect">
             <a:avLst/>
@@ -2329,14 +2361,17 @@
               <a:buNone/>
             </a:pPr>
             <a:r>
-              <a:rPr lang="en-US" sz="1600" b="1" dirty="0">
+              <a:rPr lang="en-US" sz="1700" b="1" dirty="0">
                 <a:solidFill>
                   <a:schemeClr val="tx2"/>
                 </a:solidFill>
+                <a:latin typeface="B Nazanin" pitchFamily="34" charset="0"/>
+                <a:ea typeface="B Nazanin" pitchFamily="34" charset="-122"/>
+                <a:cs typeface="B Nazanin" pitchFamily="34" charset="-120"/>
               </a:rPr>
               <a:t>سه ویژگی اصلی</a:t>
             </a:r>
-            <a:endParaRPr lang="en-US" sz="1600" dirty="0"/>
+            <a:endParaRPr lang="en-US" sz="1700" dirty="0"/>
           </a:p>
         </p:txBody>
       </p:sp>
@@ -2348,8 +2383,8 @@
         </p:nvSpPr>
         <p:spPr>
           <a:xfrm>
-            <a:off x="594360" y="1801368"/>
-            <a:ext cx="3703320" cy="1920240"/>
+            <a:off x="594360" y="2011680"/>
+            <a:ext cx="3703320" cy="1874520"/>
           </a:xfrm>
           <a:prstGeom prst="rect">
             <a:avLst/>
@@ -2369,14 +2404,17 @@
               <a:buChar char="•"/>
             </a:pPr>
             <a:r>
-              <a:rPr lang="en-US" sz="1400" dirty="0">
+              <a:rPr lang="en-US" sz="1500" dirty="0">
                 <a:solidFill>
                   <a:schemeClr val="tx1"/>
                 </a:solidFill>
+                <a:latin typeface="B Nazanin" pitchFamily="34" charset="0"/>
+                <a:ea typeface="B Nazanin" pitchFamily="34" charset="-122"/>
+                <a:cs typeface="B Nazanin" pitchFamily="34" charset="-120"/>
               </a:rPr>
               <a:t>پاسخگویی به حاکم</a:t>
             </a:r>
-            <a:endParaRPr lang="en-US" sz="1400" dirty="0"/>
+            <a:endParaRPr lang="en-US" sz="1500" dirty="0"/>
           </a:p>
           <a:p>
             <a:pPr algn="r" marL="342900" indent="-342900">
@@ -2387,14 +2425,17 @@
               <a:buChar char="•"/>
             </a:pPr>
             <a:r>
-              <a:rPr lang="en-US" sz="1400" dirty="0">
+              <a:rPr lang="en-US" sz="1500" dirty="0">
                 <a:solidFill>
                   <a:schemeClr val="tx1"/>
                 </a:solidFill>
+                <a:latin typeface="B Nazanin" pitchFamily="34" charset="0"/>
+                <a:ea typeface="B Nazanin" pitchFamily="34" charset="-122"/>
+                <a:cs typeface="B Nazanin" pitchFamily="34" charset="-120"/>
               </a:rPr>
               <a:t>پاسخگویی به حزب</a:t>
             </a:r>
-            <a:endParaRPr lang="en-US" sz="1400" dirty="0"/>
+            <a:endParaRPr lang="en-US" sz="1500" dirty="0"/>
           </a:p>
           <a:p>
             <a:pPr algn="r" marL="342900" indent="-342900">
@@ -2405,14 +2446,17 @@
               <a:buChar char="•"/>
             </a:pPr>
             <a:r>
-              <a:rPr lang="en-US" sz="1400" dirty="0">
+              <a:rPr lang="en-US" sz="1500" dirty="0">
                 <a:solidFill>
                   <a:schemeClr val="tx1"/>
                 </a:solidFill>
+                <a:latin typeface="B Nazanin" pitchFamily="34" charset="0"/>
+                <a:ea typeface="B Nazanin" pitchFamily="34" charset="-122"/>
+                <a:cs typeface="B Nazanin" pitchFamily="34" charset="-120"/>
               </a:rPr>
               <a:t>پاسخگویی به ارتش</a:t>
             </a:r>
-            <a:endParaRPr lang="en-US" sz="1400" dirty="0"/>
+            <a:endParaRPr lang="en-US" sz="1500" dirty="0"/>
           </a:p>
         </p:txBody>
       </p:sp>
@@ -2424,12 +2468,12 @@
         </p:nvSpPr>
         <p:spPr>
           <a:xfrm>
-            <a:off x="457200" y="3931920"/>
-            <a:ext cx="8229600" cy="777240"/>
+            <a:off x="457200" y="4069080"/>
+            <a:ext cx="8229600" cy="640080"/>
           </a:xfrm>
           <a:prstGeom prst="roundRect">
             <a:avLst>
-              <a:gd name="adj" fmla="val 11765"/>
+              <a:gd name="adj" fmla="val 14286"/>
             </a:avLst>
           </a:prstGeom>
           <a:solidFill>
@@ -2451,8 +2495,8 @@
         </p:nvSpPr>
         <p:spPr>
           <a:xfrm>
-            <a:off x="640080" y="3931920"/>
-            <a:ext cx="7863840" cy="777240"/>
+            <a:off x="640080" y="4069080"/>
+            <a:ext cx="7863840" cy="640080"/>
           </a:xfrm>
           <a:prstGeom prst="rect">
             <a:avLst/>
@@ -2468,10 +2512,13 @@
               <a:buNone/>
             </a:pPr>
             <a:r>
-              <a:rPr lang="en-US" sz="1400" dirty="0">
+              <a:rPr lang="en-US" sz="1600" dirty="0">
                 <a:solidFill>
                   <a:schemeClr val="tx1"/>
                 </a:solidFill>
+                <a:latin typeface="B Nazanin" pitchFamily="34" charset="0"/>
+                <a:ea typeface="B Nazanin" pitchFamily="34" charset="-122"/>
+                <a:cs typeface="B Nazanin" pitchFamily="34" charset="-120"/>
               </a:rPr>
               <a:t>💡 </a:t>
             </a:r>
@@ -2479,14 +2526,17 @@
               <a:buNone/>
             </a:pPr>
             <a:r>
-              <a:rPr lang="en-US" sz="1400" dirty="0">
+              <a:rPr lang="en-US" sz="1600" dirty="0">
                 <a:solidFill>
                   <a:schemeClr val="tx1"/>
                 </a:solidFill>
+                <a:latin typeface="B Nazanin" pitchFamily="34" charset="0"/>
+                <a:ea typeface="B Nazanin" pitchFamily="34" charset="-122"/>
+                <a:cs typeface="B Nazanin" pitchFamily="34" charset="-120"/>
               </a:rPr>
               <a:t>پاسخگویی به «حاکم» ← بوروکراسی سیاسی و وابسته. پاسخگویی به «قانون» ← بوروکراسی حرفه‌ای‌تر و مستقل‌تر.</a:t>
             </a:r>
-            <a:endParaRPr lang="en-US" sz="1400" dirty="0"/>
+            <a:endParaRPr lang="en-US" sz="1600" dirty="0"/>
           </a:p>
         </p:txBody>
       </p:sp>
@@ -2587,14 +2637,17 @@
               <a:buNone/>
             </a:pPr>
             <a:r>
-              <a:rPr lang="en-US" sz="3200" b="1" dirty="0">
+              <a:rPr lang="en-US" sz="3400" dirty="0">
                 <a:solidFill>
                   <a:schemeClr val="accent1"/>
                 </a:solidFill>
+                <a:latin typeface="B Titr" pitchFamily="34" charset="0"/>
+                <a:ea typeface="B Titr" pitchFamily="34" charset="-122"/>
+                <a:cs typeface="B Titr" pitchFamily="34" charset="-120"/>
               </a:rPr>
               <a:t>جمع‌بندی و نتیجه‌گیری</a:t>
             </a:r>
-            <a:endParaRPr lang="en-US" sz="3200" dirty="0"/>
+            <a:endParaRPr lang="en-US" sz="3400" dirty="0"/>
           </a:p>
         </p:txBody>
       </p:sp>
@@ -2607,7 +2660,7 @@
         <p:spPr>
           <a:xfrm>
             <a:off x="6126480" y="1234440"/>
-            <a:ext cx="2560320" cy="2606040"/>
+            <a:ext cx="2560320" cy="2743200"/>
           </a:xfrm>
           <a:prstGeom prst="roundRect">
             <a:avLst>
@@ -2633,8 +2686,8 @@
         </p:nvSpPr>
         <p:spPr>
           <a:xfrm>
-            <a:off x="6263640" y="1344168"/>
-            <a:ext cx="2286000" cy="411480"/>
+            <a:off x="6263640" y="1325880"/>
+            <a:ext cx="2286000" cy="640080"/>
           </a:xfrm>
           <a:prstGeom prst="rect">
             <a:avLst/>
@@ -2650,14 +2703,17 @@
               <a:buNone/>
             </a:pPr>
             <a:r>
-              <a:rPr lang="en-US" sz="1600" b="1" dirty="0">
+              <a:rPr lang="en-US" sz="1700" b="1" dirty="0">
                 <a:solidFill>
                   <a:schemeClr val="tx2"/>
                 </a:solidFill>
+                <a:latin typeface="B Nazanin" pitchFamily="34" charset="0"/>
+                <a:ea typeface="B Nazanin" pitchFamily="34" charset="-122"/>
+                <a:cs typeface="B Nazanin" pitchFamily="34" charset="-120"/>
               </a:rPr>
               <a:t>ریگز و مدل منشوری</a:t>
             </a:r>
-            <a:endParaRPr lang="en-US" sz="1600" dirty="0"/>
+            <a:endParaRPr lang="en-US" sz="1700" dirty="0"/>
           </a:p>
         </p:txBody>
       </p:sp>
@@ -2669,8 +2725,8 @@
         </p:nvSpPr>
         <p:spPr>
           <a:xfrm>
-            <a:off x="6263640" y="1801368"/>
-            <a:ext cx="2286000" cy="1920240"/>
+            <a:off x="6263640" y="2011680"/>
+            <a:ext cx="2286000" cy="1874520"/>
           </a:xfrm>
           <a:prstGeom prst="rect">
             <a:avLst/>
@@ -2690,14 +2746,17 @@
               <a:buChar char="•"/>
             </a:pPr>
             <a:r>
-              <a:rPr lang="en-US" sz="1400" dirty="0">
+              <a:rPr lang="en-US" sz="1500" dirty="0">
                 <a:solidFill>
                   <a:schemeClr val="tx1"/>
                 </a:solidFill>
+                <a:latin typeface="B Nazanin" pitchFamily="34" charset="0"/>
+                <a:ea typeface="B Nazanin" pitchFamily="34" charset="-122"/>
+                <a:cs typeface="B Nazanin" pitchFamily="34" charset="-120"/>
               </a:rPr>
               <a:t>بهترین چارچوب برای تحلیل بوروکراسی در کشورهای در حال توسعه</a:t>
             </a:r>
-            <a:endParaRPr lang="en-US" sz="1400" dirty="0"/>
+            <a:endParaRPr lang="en-US" sz="1500" dirty="0"/>
           </a:p>
         </p:txBody>
       </p:sp>
@@ -2710,7 +2769,7 @@
         <p:spPr>
           <a:xfrm>
             <a:off x="3291840" y="1234440"/>
-            <a:ext cx="2560320" cy="2606040"/>
+            <a:ext cx="2560320" cy="2743200"/>
           </a:xfrm>
           <a:prstGeom prst="roundRect">
             <a:avLst>
@@ -2736,8 +2795,8 @@
         </p:nvSpPr>
         <p:spPr>
           <a:xfrm>
-            <a:off x="3429000" y="1344168"/>
-            <a:ext cx="2286000" cy="411480"/>
+            <a:off x="3429000" y="1325880"/>
+            <a:ext cx="2286000" cy="640080"/>
           </a:xfrm>
           <a:prstGeom prst="rect">
             <a:avLst/>
@@ -2753,14 +2812,17 @@
               <a:buNone/>
             </a:pPr>
             <a:r>
-              <a:rPr lang="en-US" sz="1600" b="1" dirty="0">
+              <a:rPr lang="en-US" sz="1700" b="1" dirty="0">
                 <a:solidFill>
                   <a:schemeClr val="tx2"/>
                 </a:solidFill>
+                <a:latin typeface="B Nazanin" pitchFamily="34" charset="0"/>
+                <a:ea typeface="B Nazanin" pitchFamily="34" charset="-122"/>
+                <a:cs typeface="B Nazanin" pitchFamily="34" charset="-120"/>
               </a:rPr>
               <a:t>چالش اصلی</a:t>
             </a:r>
-            <a:endParaRPr lang="en-US" sz="1600" dirty="0"/>
+            <a:endParaRPr lang="en-US" sz="1700" dirty="0"/>
           </a:p>
         </p:txBody>
       </p:sp>
@@ -2772,8 +2834,8 @@
         </p:nvSpPr>
         <p:spPr>
           <a:xfrm>
-            <a:off x="3429000" y="1801368"/>
-            <a:ext cx="2286000" cy="1920240"/>
+            <a:off x="3429000" y="2011680"/>
+            <a:ext cx="2286000" cy="1874520"/>
           </a:xfrm>
           <a:prstGeom prst="rect">
             <a:avLst/>
@@ -2793,14 +2855,17 @@
               <a:buChar char="•"/>
             </a:pPr>
             <a:r>
-              <a:rPr lang="en-US" sz="1400" dirty="0">
+              <a:rPr lang="en-US" sz="1500" dirty="0">
                 <a:solidFill>
                   <a:schemeClr val="tx1"/>
                 </a:solidFill>
+                <a:latin typeface="B Nazanin" pitchFamily="34" charset="0"/>
+                <a:ea typeface="B Nazanin" pitchFamily="34" charset="-122"/>
+                <a:cs typeface="B Nazanin" pitchFamily="34" charset="-120"/>
               </a:rPr>
               <a:t>عدم تطابق بین ساختارهای مدرن و کارکردهای سنتی</a:t>
             </a:r>
-            <a:endParaRPr lang="en-US" sz="1400" dirty="0"/>
+            <a:endParaRPr lang="en-US" sz="1500" dirty="0"/>
           </a:p>
         </p:txBody>
       </p:sp>
@@ -2813,7 +2878,7 @@
         <p:spPr>
           <a:xfrm>
             <a:off x="457200" y="1234440"/>
-            <a:ext cx="2560320" cy="2606040"/>
+            <a:ext cx="2560320" cy="2743200"/>
           </a:xfrm>
           <a:prstGeom prst="roundRect">
             <a:avLst>
@@ -2839,8 +2904,8 @@
         </p:nvSpPr>
         <p:spPr>
           <a:xfrm>
-            <a:off x="594360" y="1344168"/>
-            <a:ext cx="2286000" cy="411480"/>
+            <a:off x="594360" y="1325880"/>
+            <a:ext cx="2286000" cy="640080"/>
           </a:xfrm>
           <a:prstGeom prst="rect">
             <a:avLst/>
@@ -2856,14 +2921,17 @@
               <a:buNone/>
             </a:pPr>
             <a:r>
-              <a:rPr lang="en-US" sz="1600" b="1" dirty="0">
+              <a:rPr lang="en-US" sz="1700" b="1" dirty="0">
                 <a:solidFill>
                   <a:schemeClr val="tx2"/>
                 </a:solidFill>
+                <a:latin typeface="B Nazanin" pitchFamily="34" charset="0"/>
+                <a:ea typeface="B Nazanin" pitchFamily="34" charset="-122"/>
+                <a:cs typeface="B Nazanin" pitchFamily="34" charset="-120"/>
               </a:rPr>
               <a:t>راهکار</a:t>
             </a:r>
-            <a:endParaRPr lang="en-US" sz="1600" dirty="0"/>
+            <a:endParaRPr lang="en-US" sz="1700" dirty="0"/>
           </a:p>
         </p:txBody>
       </p:sp>
@@ -2875,8 +2943,8 @@
         </p:nvSpPr>
         <p:spPr>
           <a:xfrm>
-            <a:off x="594360" y="1801368"/>
-            <a:ext cx="2286000" cy="1920240"/>
+            <a:off x="594360" y="2011680"/>
+            <a:ext cx="2286000" cy="1874520"/>
           </a:xfrm>
           <a:prstGeom prst="rect">
             <a:avLst/>
@@ -2896,14 +2964,17 @@
               <a:buChar char="•"/>
             </a:pPr>
             <a:r>
-              <a:rPr lang="en-US" sz="1400" dirty="0">
+              <a:rPr lang="en-US" sz="1500" dirty="0">
                 <a:solidFill>
                   <a:schemeClr val="tx1"/>
                 </a:solidFill>
+                <a:latin typeface="B Nazanin" pitchFamily="34" charset="0"/>
+                <a:ea typeface="B Nazanin" pitchFamily="34" charset="-122"/>
+                <a:cs typeface="B Nazanin" pitchFamily="34" charset="-120"/>
               </a:rPr>
               <a:t>درک بوم‌شناسی اداری (محیط سیاسی، اجتماعی و فرهنگی) قبل از هرگونه اصلاحات اداری</a:t>
             </a:r>
-            <a:endParaRPr lang="en-US" sz="1400" dirty="0"/>
+            <a:endParaRPr lang="en-US" sz="1500" dirty="0"/>
           </a:p>
         </p:txBody>
       </p:sp>
@@ -2915,12 +2986,12 @@
         </p:nvSpPr>
         <p:spPr>
           <a:xfrm>
-            <a:off x="457200" y="3931920"/>
-            <a:ext cx="8229600" cy="777240"/>
+            <a:off x="457200" y="4069080"/>
+            <a:ext cx="8229600" cy="640080"/>
           </a:xfrm>
           <a:prstGeom prst="roundRect">
             <a:avLst>
-              <a:gd name="adj" fmla="val 11765"/>
+              <a:gd name="adj" fmla="val 14286"/>
             </a:avLst>
           </a:prstGeom>
           <a:solidFill>
@@ -2942,8 +3013,8 @@
         </p:nvSpPr>
         <p:spPr>
           <a:xfrm>
-            <a:off x="640080" y="3931920"/>
-            <a:ext cx="7863840" cy="777240"/>
+            <a:off x="640080" y="4069080"/>
+            <a:ext cx="7863840" cy="640080"/>
           </a:xfrm>
           <a:prstGeom prst="rect">
             <a:avLst/>
@@ -2959,10 +3030,13 @@
               <a:buNone/>
             </a:pPr>
             <a:r>
-              <a:rPr lang="en-US" sz="1400" dirty="0">
+              <a:rPr lang="en-US" sz="1600" dirty="0">
                 <a:solidFill>
                   <a:schemeClr val="tx1"/>
                 </a:solidFill>
+                <a:latin typeface="B Nazanin" pitchFamily="34" charset="0"/>
+                <a:ea typeface="B Nazanin" pitchFamily="34" charset="-122"/>
+                <a:cs typeface="B Nazanin" pitchFamily="34" charset="-120"/>
               </a:rPr>
               <a:t>💡 </a:t>
             </a:r>
@@ -2970,14 +3044,17 @@
               <a:buNone/>
             </a:pPr>
             <a:r>
-              <a:rPr lang="en-US" sz="1400" dirty="0">
+              <a:rPr lang="en-US" sz="1600" dirty="0">
                 <a:solidFill>
                   <a:schemeClr val="tx1"/>
                 </a:solidFill>
+                <a:latin typeface="B Nazanin" pitchFamily="34" charset="0"/>
+                <a:ea typeface="B Nazanin" pitchFamily="34" charset="-122"/>
+                <a:cs typeface="B Nazanin" pitchFamily="34" charset="-120"/>
               </a:rPr>
               <a:t>سخن آخر: بوروکراسی صرفاً یک ابزار فنی نیست، بلکه بازتابی از فرهنگ و سیاست هر جامعه است.</a:t>
             </a:r>
-            <a:endParaRPr lang="en-US" sz="1400" dirty="0"/>
+            <a:endParaRPr lang="en-US" sz="1600" dirty="0"/>
           </a:p>
         </p:txBody>
       </p:sp>
@@ -3078,14 +3155,17 @@
               <a:buNone/>
             </a:pPr>
             <a:r>
-              <a:rPr lang="en-US" sz="3200" b="1" dirty="0">
+              <a:rPr lang="en-US" sz="3400" dirty="0">
                 <a:solidFill>
                   <a:schemeClr val="accent1"/>
                 </a:solidFill>
+                <a:latin typeface="B Titr" pitchFamily="34" charset="0"/>
+                <a:ea typeface="B Titr" pitchFamily="34" charset="-122"/>
+                <a:cs typeface="B Titr" pitchFamily="34" charset="-120"/>
               </a:rPr>
               <a:t>نکات کلیدی برای ارائه در کلاس</a:t>
             </a:r>
-            <a:endParaRPr lang="en-US" sz="3200" dirty="0"/>
+            <a:endParaRPr lang="en-US" sz="3400" dirty="0"/>
           </a:p>
         </p:txBody>
       </p:sp>
@@ -3166,14 +3246,17 @@
               <a:buNone/>
             </a:pPr>
             <a:r>
-              <a:rPr lang="en-US" sz="1600" b="1" dirty="0">
+              <a:rPr lang="en-US" sz="1800" b="1" dirty="0">
                 <a:solidFill>
                   <a:schemeClr val="bg1"/>
                 </a:solidFill>
+                <a:latin typeface="B Nazanin" pitchFamily="34" charset="0"/>
+                <a:ea typeface="B Nazanin" pitchFamily="34" charset="-122"/>
+                <a:cs typeface="B Nazanin" pitchFamily="34" charset="-120"/>
               </a:rPr>
               <a:t>۱</a:t>
             </a:r>
-            <a:endParaRPr lang="en-US" sz="1600" dirty="0"/>
+            <a:endParaRPr lang="en-US" sz="1800" dirty="0"/>
           </a:p>
         </p:txBody>
       </p:sp>
@@ -3202,14 +3285,17 @@
               <a:buNone/>
             </a:pPr>
             <a:r>
-              <a:rPr lang="en-US" sz="1500" dirty="0">
+              <a:rPr lang="en-US" sz="1700" dirty="0">
                 <a:solidFill>
                   <a:schemeClr val="tx1"/>
                 </a:solidFill>
+                <a:latin typeface="B Nazanin" pitchFamily="34" charset="0"/>
+                <a:ea typeface="B Nazanin" pitchFamily="34" charset="-122"/>
+                <a:cs typeface="B Nazanin" pitchFamily="34" charset="-120"/>
               </a:rPr>
               <a:t>استفاده از نمودارها: نمودار درختی مدل‌های ریگز را روی تخته یا اسلاید بکشید</a:t>
             </a:r>
-            <a:endParaRPr lang="en-US" sz="1500" dirty="0"/>
+            <a:endParaRPr lang="en-US" sz="1700" dirty="0"/>
           </a:p>
         </p:txBody>
       </p:sp>
@@ -3290,14 +3376,17 @@
               <a:buNone/>
             </a:pPr>
             <a:r>
-              <a:rPr lang="en-US" sz="1600" b="1" dirty="0">
+              <a:rPr lang="en-US" sz="1800" b="1" dirty="0">
                 <a:solidFill>
                   <a:schemeClr val="bg1"/>
                 </a:solidFill>
+                <a:latin typeface="B Nazanin" pitchFamily="34" charset="0"/>
+                <a:ea typeface="B Nazanin" pitchFamily="34" charset="-122"/>
+                <a:cs typeface="B Nazanin" pitchFamily="34" charset="-120"/>
               </a:rPr>
               <a:t>۲</a:t>
             </a:r>
-            <a:endParaRPr lang="en-US" sz="1600" dirty="0"/>
+            <a:endParaRPr lang="en-US" sz="1800" dirty="0"/>
           </a:p>
         </p:txBody>
       </p:sp>
@@ -3326,14 +3415,17 @@
               <a:buNone/>
             </a:pPr>
             <a:r>
-              <a:rPr lang="en-US" sz="1500" dirty="0">
+              <a:rPr lang="en-US" sz="1700" dirty="0">
                 <a:solidFill>
                   <a:schemeClr val="tx1"/>
                 </a:solidFill>
+                <a:latin typeface="B Nazanin" pitchFamily="34" charset="0"/>
+                <a:ea typeface="B Nazanin" pitchFamily="34" charset="-122"/>
+                <a:cs typeface="B Nazanin" pitchFamily="34" charset="-120"/>
               </a:rPr>
               <a:t>مثال‌های عینی: برای مدل «منشوری»، مثال سازمان‌های دولتی در ایران را ذکر کنید</a:t>
             </a:r>
-            <a:endParaRPr lang="en-US" sz="1500" dirty="0"/>
+            <a:endParaRPr lang="en-US" sz="1700" dirty="0"/>
           </a:p>
         </p:txBody>
       </p:sp>
@@ -3414,14 +3506,17 @@
               <a:buNone/>
             </a:pPr>
             <a:r>
-              <a:rPr lang="en-US" sz="1600" b="1" dirty="0">
+              <a:rPr lang="en-US" sz="1800" b="1" dirty="0">
                 <a:solidFill>
                   <a:schemeClr val="bg1"/>
                 </a:solidFill>
+                <a:latin typeface="B Nazanin" pitchFamily="34" charset="0"/>
+                <a:ea typeface="B Nazanin" pitchFamily="34" charset="-122"/>
+                <a:cs typeface="B Nazanin" pitchFamily="34" charset="-120"/>
               </a:rPr>
               <a:t>۳</a:t>
             </a:r>
-            <a:endParaRPr lang="en-US" sz="1600" dirty="0"/>
+            <a:endParaRPr lang="en-US" sz="1800" dirty="0"/>
           </a:p>
         </p:txBody>
       </p:sp>
@@ -3450,14 +3545,17 @@
               <a:buNone/>
             </a:pPr>
             <a:r>
-              <a:rPr lang="en-US" sz="1500" dirty="0">
+              <a:rPr lang="en-US" sz="1700" dirty="0">
                 <a:solidFill>
                   <a:schemeClr val="tx1"/>
                 </a:solidFill>
+                <a:latin typeface="B Nazanin" pitchFamily="34" charset="0"/>
+                <a:ea typeface="B Nazanin" pitchFamily="34" charset="-122"/>
+                <a:cs typeface="B Nazanin" pitchFamily="34" charset="-120"/>
               </a:rPr>
               <a:t>پرسش و پاسخ: از همکلاسی‌ها بپرسید: «به نظر شما بوروکراسی در ایران بیشتر به مدل وبری نزدیک است یا مدل منشوری ریگز؟»</a:t>
             </a:r>
-            <a:endParaRPr lang="en-US" sz="1500" dirty="0"/>
+            <a:endParaRPr lang="en-US" sz="1700" dirty="0"/>
           </a:p>
         </p:txBody>
       </p:sp>
@@ -3558,14 +3656,17 @@
               <a:buNone/>
             </a:pPr>
             <a:r>
-              <a:rPr lang="en-US" sz="3200" b="1" dirty="0">
+              <a:rPr lang="en-US" sz="3400" dirty="0">
                 <a:solidFill>
                   <a:schemeClr val="accent1"/>
                 </a:solidFill>
+                <a:latin typeface="B Titr" pitchFamily="34" charset="0"/>
+                <a:ea typeface="B Titr" pitchFamily="34" charset="-122"/>
+                <a:cs typeface="B Titr" pitchFamily="34" charset="-120"/>
               </a:rPr>
               <a:t>مقدمه و مفهوم «ریگز»</a:t>
             </a:r>
-            <a:endParaRPr lang="en-US" sz="3200" dirty="0"/>
+            <a:endParaRPr lang="en-US" sz="3400" dirty="0"/>
           </a:p>
         </p:txBody>
       </p:sp>
@@ -3578,11 +3679,11 @@
         <p:spPr>
           <a:xfrm>
             <a:off x="4709160" y="1234440"/>
-            <a:ext cx="3977640" cy="2606040"/>
+            <a:ext cx="3977640" cy="2743200"/>
           </a:xfrm>
           <a:prstGeom prst="roundRect">
             <a:avLst>
-              <a:gd name="adj" fmla="val 3509"/>
+              <a:gd name="adj" fmla="val 3333"/>
             </a:avLst>
           </a:prstGeom>
           <a:solidFill>
@@ -3604,8 +3705,8 @@
         </p:nvSpPr>
         <p:spPr>
           <a:xfrm>
-            <a:off x="4846320" y="1344168"/>
-            <a:ext cx="3703320" cy="411480"/>
+            <a:off x="4846320" y="1325880"/>
+            <a:ext cx="3703320" cy="640080"/>
           </a:xfrm>
           <a:prstGeom prst="rect">
             <a:avLst/>
@@ -3621,14 +3722,17 @@
               <a:buNone/>
             </a:pPr>
             <a:r>
-              <a:rPr lang="en-US" sz="1600" b="1" dirty="0">
+              <a:rPr lang="en-US" sz="1700" b="1" dirty="0">
                 <a:solidFill>
                   <a:schemeClr val="tx2"/>
                 </a:solidFill>
+                <a:latin typeface="B Nazanin" pitchFamily="34" charset="0"/>
+                <a:ea typeface="B Nazanin" pitchFamily="34" charset="-122"/>
+                <a:cs typeface="B Nazanin" pitchFamily="34" charset="-120"/>
               </a:rPr>
               <a:t>فرد ریگز (Riggs)</a:t>
             </a:r>
-            <a:endParaRPr lang="en-US" sz="1600" dirty="0"/>
+            <a:endParaRPr lang="en-US" sz="1700" dirty="0"/>
           </a:p>
         </p:txBody>
       </p:sp>
@@ -3640,8 +3744,8 @@
         </p:nvSpPr>
         <p:spPr>
           <a:xfrm>
-            <a:off x="4846320" y="1801368"/>
-            <a:ext cx="3703320" cy="1920240"/>
+            <a:off x="4846320" y="2011680"/>
+            <a:ext cx="3703320" cy="1874520"/>
           </a:xfrm>
           <a:prstGeom prst="rect">
             <a:avLst/>
@@ -3661,14 +3765,17 @@
               <a:buChar char="•"/>
             </a:pPr>
             <a:r>
-              <a:rPr lang="en-US" sz="1400" dirty="0">
+              <a:rPr lang="en-US" sz="1500" dirty="0">
                 <a:solidFill>
                   <a:schemeClr val="tx1"/>
                 </a:solidFill>
+                <a:latin typeface="B Nazanin" pitchFamily="34" charset="0"/>
+                <a:ea typeface="B Nazanin" pitchFamily="34" charset="-122"/>
+                <a:cs typeface="B Nazanin" pitchFamily="34" charset="-120"/>
               </a:rPr>
               <a:t>تئوری منشوری (Prismatic Theory)</a:t>
             </a:r>
-            <a:endParaRPr lang="en-US" sz="1400" dirty="0"/>
+            <a:endParaRPr lang="en-US" sz="1500" dirty="0"/>
           </a:p>
           <a:p>
             <a:pPr algn="r" marL="342900" indent="-342900">
@@ -3679,14 +3786,17 @@
               <a:buChar char="•"/>
             </a:pPr>
             <a:r>
-              <a:rPr lang="en-US" sz="1400" dirty="0">
+              <a:rPr lang="en-US" sz="1500" dirty="0">
                 <a:solidFill>
                   <a:schemeClr val="tx1"/>
                 </a:solidFill>
+                <a:latin typeface="B Nazanin" pitchFamily="34" charset="0"/>
+                <a:ea typeface="B Nazanin" pitchFamily="34" charset="-122"/>
+                <a:cs typeface="B Nazanin" pitchFamily="34" charset="-120"/>
               </a:rPr>
               <a:t>کشورهای در حال توسعه = ساختارهای «منشوری» (ترکیب سنت + مدرنیته)</a:t>
             </a:r>
-            <a:endParaRPr lang="en-US" sz="1400" dirty="0"/>
+            <a:endParaRPr lang="en-US" sz="1500" dirty="0"/>
           </a:p>
         </p:txBody>
       </p:sp>
@@ -3699,11 +3809,11 @@
         <p:spPr>
           <a:xfrm>
             <a:off x="457200" y="1234440"/>
-            <a:ext cx="3977640" cy="2606040"/>
+            <a:ext cx="3977640" cy="2743200"/>
           </a:xfrm>
           <a:prstGeom prst="roundRect">
             <a:avLst>
-              <a:gd name="adj" fmla="val 3509"/>
+              <a:gd name="adj" fmla="val 3333"/>
             </a:avLst>
           </a:prstGeom>
           <a:solidFill>
@@ -3725,8 +3835,8 @@
         </p:nvSpPr>
         <p:spPr>
           <a:xfrm>
-            <a:off x="594360" y="1344168"/>
-            <a:ext cx="3703320" cy="411480"/>
+            <a:off x="594360" y="1325880"/>
+            <a:ext cx="3703320" cy="640080"/>
           </a:xfrm>
           <a:prstGeom prst="rect">
             <a:avLst/>
@@ -3742,14 +3852,17 @@
               <a:buNone/>
             </a:pPr>
             <a:r>
-              <a:rPr lang="en-US" sz="1600" b="1" dirty="0">
+              <a:rPr lang="en-US" sz="1700" b="1" dirty="0">
                 <a:solidFill>
                   <a:schemeClr val="tx2"/>
                 </a:solidFill>
+                <a:latin typeface="B Nazanin" pitchFamily="34" charset="0"/>
+                <a:ea typeface="B Nazanin" pitchFamily="34" charset="-122"/>
+                <a:cs typeface="B Nazanin" pitchFamily="34" charset="-120"/>
               </a:rPr>
               <a:t>مفهوم «سالا» (Sala)</a:t>
             </a:r>
-            <a:endParaRPr lang="en-US" sz="1600" dirty="0"/>
+            <a:endParaRPr lang="en-US" sz="1700" dirty="0"/>
           </a:p>
         </p:txBody>
       </p:sp>
@@ -3761,8 +3874,8 @@
         </p:nvSpPr>
         <p:spPr>
           <a:xfrm>
-            <a:off x="594360" y="1801368"/>
-            <a:ext cx="3703320" cy="1920240"/>
+            <a:off x="594360" y="2011680"/>
+            <a:ext cx="3703320" cy="1874520"/>
           </a:xfrm>
           <a:prstGeom prst="rect">
             <a:avLst/>
@@ -3782,14 +3895,17 @@
               <a:buChar char="•"/>
             </a:pPr>
             <a:r>
-              <a:rPr lang="en-US" sz="1400" dirty="0">
+              <a:rPr lang="en-US" sz="1500" dirty="0">
                 <a:solidFill>
                   <a:schemeClr val="tx1"/>
                 </a:solidFill>
+                <a:latin typeface="B Nazanin" pitchFamily="34" charset="0"/>
+                <a:ea typeface="B Nazanin" pitchFamily="34" charset="-122"/>
+                <a:cs typeface="B Nazanin" pitchFamily="34" charset="-120"/>
               </a:rPr>
               <a:t>دیوان (Bureau): هر سه مدل (متمرکز، مرکب، وسیع)</a:t>
             </a:r>
-            <a:endParaRPr lang="en-US" sz="1400" dirty="0"/>
+            <a:endParaRPr lang="en-US" sz="1500" dirty="0"/>
           </a:p>
           <a:p>
             <a:pPr algn="r" marL="342900" indent="-342900">
@@ -3800,14 +3916,17 @@
               <a:buChar char="•"/>
             </a:pPr>
             <a:r>
-              <a:rPr lang="en-US" sz="1400" dirty="0">
+              <a:rPr lang="en-US" sz="1500" dirty="0">
                 <a:solidFill>
                   <a:schemeClr val="tx1"/>
                 </a:solidFill>
+                <a:latin typeface="B Nazanin" pitchFamily="34" charset="0"/>
+                <a:ea typeface="B Nazanin" pitchFamily="34" charset="-122"/>
+                <a:cs typeface="B Nazanin" pitchFamily="34" charset="-120"/>
               </a:rPr>
               <a:t>اتاق (Chamber): بوروکراسی مرکب</a:t>
             </a:r>
-            <a:endParaRPr lang="en-US" sz="1400" dirty="0"/>
+            <a:endParaRPr lang="en-US" sz="1500" dirty="0"/>
           </a:p>
           <a:p>
             <a:pPr algn="r" marL="342900" indent="-342900">
@@ -3818,14 +3937,17 @@
               <a:buChar char="•"/>
             </a:pPr>
             <a:r>
-              <a:rPr lang="en-US" sz="1400" dirty="0">
+              <a:rPr lang="en-US" sz="1500" dirty="0">
                 <a:solidFill>
                   <a:schemeClr val="tx1"/>
                 </a:solidFill>
+                <a:latin typeface="B Nazanin" pitchFamily="34" charset="0"/>
+                <a:ea typeface="B Nazanin" pitchFamily="34" charset="-122"/>
+                <a:cs typeface="B Nazanin" pitchFamily="34" charset="-120"/>
               </a:rPr>
               <a:t>اداره (Office): بوروکراسی وسیع و جدید</a:t>
             </a:r>
-            <a:endParaRPr lang="en-US" sz="1400" dirty="0"/>
+            <a:endParaRPr lang="en-US" sz="1500" dirty="0"/>
           </a:p>
         </p:txBody>
       </p:sp>
@@ -3837,12 +3959,12 @@
         </p:nvSpPr>
         <p:spPr>
           <a:xfrm>
-            <a:off x="457200" y="3931920"/>
-            <a:ext cx="8229600" cy="777240"/>
+            <a:off x="457200" y="4069080"/>
+            <a:ext cx="8229600" cy="640080"/>
           </a:xfrm>
           <a:prstGeom prst="roundRect">
             <a:avLst>
-              <a:gd name="adj" fmla="val 11765"/>
+              <a:gd name="adj" fmla="val 14286"/>
             </a:avLst>
           </a:prstGeom>
           <a:solidFill>
@@ -3864,8 +3986,8 @@
         </p:nvSpPr>
         <p:spPr>
           <a:xfrm>
-            <a:off x="640080" y="3931920"/>
-            <a:ext cx="7863840" cy="777240"/>
+            <a:off x="640080" y="4069080"/>
+            <a:ext cx="7863840" cy="640080"/>
           </a:xfrm>
           <a:prstGeom prst="rect">
             <a:avLst/>
@@ -3881,10 +4003,13 @@
               <a:buNone/>
             </a:pPr>
             <a:r>
-              <a:rPr lang="en-US" sz="1400" dirty="0">
+              <a:rPr lang="en-US" sz="1600" dirty="0">
                 <a:solidFill>
                   <a:schemeClr val="tx1"/>
                 </a:solidFill>
+                <a:latin typeface="B Nazanin" pitchFamily="34" charset="0"/>
+                <a:ea typeface="B Nazanin" pitchFamily="34" charset="-122"/>
+                <a:cs typeface="B Nazanin" pitchFamily="34" charset="-120"/>
               </a:rPr>
               <a:t>💡 </a:t>
             </a:r>
@@ -3892,14 +4017,17 @@
               <a:buNone/>
             </a:pPr>
             <a:r>
-              <a:rPr lang="en-US" sz="1400" dirty="0">
+              <a:rPr lang="en-US" sz="1600" dirty="0">
                 <a:solidFill>
                   <a:schemeClr val="tx1"/>
                 </a:solidFill>
+                <a:latin typeface="B Nazanin" pitchFamily="34" charset="0"/>
+                <a:ea typeface="B Nazanin" pitchFamily="34" charset="-122"/>
+                <a:cs typeface="B Nazanin" pitchFamily="34" charset="-120"/>
               </a:rPr>
               <a:t>در جوامع در حال توسعه، ساختارها ظاهراً مدرن‌اند، اما کارکردهایشان هنوز سنتی و خانوادگی است.</a:t>
             </a:r>
-            <a:endParaRPr lang="en-US" sz="1400" dirty="0"/>
+            <a:endParaRPr lang="en-US" sz="1600" dirty="0"/>
           </a:p>
         </p:txBody>
       </p:sp>
@@ -4000,14 +4128,17 @@
               <a:buNone/>
             </a:pPr>
             <a:r>
-              <a:rPr lang="en-US" sz="3200" b="1" dirty="0">
+              <a:rPr lang="en-US" sz="3400" dirty="0">
                 <a:solidFill>
                   <a:schemeClr val="accent1"/>
                 </a:solidFill>
+                <a:latin typeface="B Titr" pitchFamily="34" charset="0"/>
+                <a:ea typeface="B Titr" pitchFamily="34" charset="-122"/>
+                <a:cs typeface="B Titr" pitchFamily="34" charset="-120"/>
               </a:rPr>
               <a:t>نقد مدل وبری</a:t>
             </a:r>
-            <a:endParaRPr lang="en-US" sz="3200" dirty="0"/>
+            <a:endParaRPr lang="en-US" sz="3400" dirty="0"/>
           </a:p>
         </p:txBody>
       </p:sp>
@@ -4020,7 +4151,7 @@
         <p:spPr>
           <a:xfrm>
             <a:off x="6126480" y="1234440"/>
-            <a:ext cx="2560320" cy="2606040"/>
+            <a:ext cx="2560320" cy="2743200"/>
           </a:xfrm>
           <a:prstGeom prst="roundRect">
             <a:avLst>
@@ -4046,8 +4177,8 @@
         </p:nvSpPr>
         <p:spPr>
           <a:xfrm>
-            <a:off x="6263640" y="1344168"/>
-            <a:ext cx="2286000" cy="411480"/>
+            <a:off x="6263640" y="1325880"/>
+            <a:ext cx="2286000" cy="640080"/>
           </a:xfrm>
           <a:prstGeom prst="rect">
             <a:avLst/>
@@ -4063,14 +4194,17 @@
               <a:buNone/>
             </a:pPr>
             <a:r>
-              <a:rPr lang="en-US" sz="1600" b="1" dirty="0">
+              <a:rPr lang="en-US" sz="1700" b="1" dirty="0">
                 <a:solidFill>
                   <a:schemeClr val="tx2"/>
                 </a:solidFill>
+                <a:latin typeface="B Nazanin" pitchFamily="34" charset="0"/>
+                <a:ea typeface="B Nazanin" pitchFamily="34" charset="-122"/>
+                <a:cs typeface="B Nazanin" pitchFamily="34" charset="-120"/>
               </a:rPr>
               <a:t>مدل وبری (عقلانی-قانونی)</a:t>
             </a:r>
-            <a:endParaRPr lang="en-US" sz="1600" dirty="0"/>
+            <a:endParaRPr lang="en-US" sz="1700" dirty="0"/>
           </a:p>
         </p:txBody>
       </p:sp>
@@ -4082,8 +4216,8 @@
         </p:nvSpPr>
         <p:spPr>
           <a:xfrm>
-            <a:off x="6263640" y="1801368"/>
-            <a:ext cx="2286000" cy="1920240"/>
+            <a:off x="6263640" y="2011680"/>
+            <a:ext cx="2286000" cy="1874520"/>
           </a:xfrm>
           <a:prstGeom prst="rect">
             <a:avLst/>
@@ -4103,14 +4237,17 @@
               <a:buChar char="•"/>
             </a:pPr>
             <a:r>
-              <a:rPr lang="en-US" sz="1400" dirty="0">
+              <a:rPr lang="en-US" sz="1500" dirty="0">
                 <a:solidFill>
                   <a:schemeClr val="tx1"/>
                 </a:solidFill>
+                <a:latin typeface="B Nazanin" pitchFamily="34" charset="0"/>
+                <a:ea typeface="B Nazanin" pitchFamily="34" charset="-122"/>
+                <a:cs typeface="B Nazanin" pitchFamily="34" charset="-120"/>
               </a:rPr>
               <a:t>سلسله‌مراتب</a:t>
             </a:r>
-            <a:endParaRPr lang="en-US" sz="1400" dirty="0"/>
+            <a:endParaRPr lang="en-US" sz="1500" dirty="0"/>
           </a:p>
           <a:p>
             <a:pPr algn="r" marL="342900" indent="-342900">
@@ -4121,14 +4258,17 @@
               <a:buChar char="•"/>
             </a:pPr>
             <a:r>
-              <a:rPr lang="en-US" sz="1400" dirty="0">
+              <a:rPr lang="en-US" sz="1500" dirty="0">
                 <a:solidFill>
                   <a:schemeClr val="tx1"/>
                 </a:solidFill>
+                <a:latin typeface="B Nazanin" pitchFamily="34" charset="0"/>
+                <a:ea typeface="B Nazanin" pitchFamily="34" charset="-122"/>
+                <a:cs typeface="B Nazanin" pitchFamily="34" charset="-120"/>
               </a:rPr>
               <a:t>تقسیم کار</a:t>
             </a:r>
-            <a:endParaRPr lang="en-US" sz="1400" dirty="0"/>
+            <a:endParaRPr lang="en-US" sz="1500" dirty="0"/>
           </a:p>
           <a:p>
             <a:pPr algn="r" marL="342900" indent="-342900">
@@ -4139,14 +4279,17 @@
               <a:buChar char="•"/>
             </a:pPr>
             <a:r>
-              <a:rPr lang="en-US" sz="1400" dirty="0">
+              <a:rPr lang="en-US" sz="1500" dirty="0">
                 <a:solidFill>
                   <a:schemeClr val="tx1"/>
                 </a:solidFill>
+                <a:latin typeface="B Nazanin" pitchFamily="34" charset="0"/>
+                <a:ea typeface="B Nazanin" pitchFamily="34" charset="-122"/>
+                <a:cs typeface="B Nazanin" pitchFamily="34" charset="-120"/>
               </a:rPr>
               <a:t>قوانین مکتوب</a:t>
             </a:r>
-            <a:endParaRPr lang="en-US" sz="1400" dirty="0"/>
+            <a:endParaRPr lang="en-US" sz="1500" dirty="0"/>
           </a:p>
           <a:p>
             <a:pPr algn="r" marL="342900" indent="-342900">
@@ -4157,14 +4300,17 @@
               <a:buChar char="•"/>
             </a:pPr>
             <a:r>
-              <a:rPr lang="en-US" sz="1400" dirty="0">
+              <a:rPr lang="en-US" sz="1500" dirty="0">
                 <a:solidFill>
                   <a:schemeClr val="tx1"/>
                 </a:solidFill>
+                <a:latin typeface="B Nazanin" pitchFamily="34" charset="0"/>
+                <a:ea typeface="B Nazanin" pitchFamily="34" charset="-122"/>
+                <a:cs typeface="B Nazanin" pitchFamily="34" charset="-120"/>
               </a:rPr>
               <a:t>تخصص</a:t>
             </a:r>
-            <a:endParaRPr lang="en-US" sz="1400" dirty="0"/>
+            <a:endParaRPr lang="en-US" sz="1500" dirty="0"/>
           </a:p>
         </p:txBody>
       </p:sp>
@@ -4177,7 +4323,7 @@
         <p:spPr>
           <a:xfrm>
             <a:off x="3291840" y="1234440"/>
-            <a:ext cx="2560320" cy="2606040"/>
+            <a:ext cx="2560320" cy="2743200"/>
           </a:xfrm>
           <a:prstGeom prst="roundRect">
             <a:avLst>
@@ -4203,8 +4349,8 @@
         </p:nvSpPr>
         <p:spPr>
           <a:xfrm>
-            <a:off x="3429000" y="1344168"/>
-            <a:ext cx="2286000" cy="411480"/>
+            <a:off x="3429000" y="1325880"/>
+            <a:ext cx="2286000" cy="640080"/>
           </a:xfrm>
           <a:prstGeom prst="rect">
             <a:avLst/>
@@ -4220,14 +4366,17 @@
               <a:buNone/>
             </a:pPr>
             <a:r>
-              <a:rPr lang="en-US" sz="1600" b="1" dirty="0">
+              <a:rPr lang="en-US" sz="1700" b="1" dirty="0">
                 <a:solidFill>
                   <a:schemeClr val="tx2"/>
                 </a:solidFill>
+                <a:latin typeface="B Nazanin" pitchFamily="34" charset="0"/>
+                <a:ea typeface="B Nazanin" pitchFamily="34" charset="-122"/>
+                <a:cs typeface="B Nazanin" pitchFamily="34" charset="-120"/>
               </a:rPr>
               <a:t>نقد ریگز به وبر</a:t>
             </a:r>
-            <a:endParaRPr lang="en-US" sz="1600" dirty="0"/>
+            <a:endParaRPr lang="en-US" sz="1700" dirty="0"/>
           </a:p>
         </p:txBody>
       </p:sp>
@@ -4239,8 +4388,8 @@
         </p:nvSpPr>
         <p:spPr>
           <a:xfrm>
-            <a:off x="3429000" y="1801368"/>
-            <a:ext cx="2286000" cy="1920240"/>
+            <a:off x="3429000" y="2011680"/>
+            <a:ext cx="2286000" cy="1874520"/>
           </a:xfrm>
           <a:prstGeom prst="rect">
             <a:avLst/>
@@ -4260,14 +4409,17 @@
               <a:buChar char="•"/>
             </a:pPr>
             <a:r>
-              <a:rPr lang="en-US" sz="1400" dirty="0">
+              <a:rPr lang="en-US" sz="1500" dirty="0">
                 <a:solidFill>
                   <a:schemeClr val="tx1"/>
                 </a:solidFill>
+                <a:latin typeface="B Nazanin" pitchFamily="34" charset="0"/>
+                <a:ea typeface="B Nazanin" pitchFamily="34" charset="-122"/>
+                <a:cs typeface="B Nazanin" pitchFamily="34" charset="-120"/>
               </a:rPr>
               <a:t>مدل وبری برای جوامع غربی طراحی شده</a:t>
             </a:r>
-            <a:endParaRPr lang="en-US" sz="1400" dirty="0"/>
+            <a:endParaRPr lang="en-US" sz="1500" dirty="0"/>
           </a:p>
           <a:p>
             <a:pPr algn="r" marL="342900" indent="-342900">
@@ -4278,14 +4430,17 @@
               <a:buChar char="•"/>
             </a:pPr>
             <a:r>
-              <a:rPr lang="en-US" sz="1400" dirty="0">
+              <a:rPr lang="en-US" sz="1500" dirty="0">
                 <a:solidFill>
                   <a:schemeClr val="tx1"/>
                 </a:solidFill>
+                <a:latin typeface="B Nazanin" pitchFamily="34" charset="0"/>
+                <a:ea typeface="B Nazanin" pitchFamily="34" charset="-122"/>
+                <a:cs typeface="B Nazanin" pitchFamily="34" charset="-120"/>
               </a:rPr>
               <a:t>برای جوامع در حال توسعه کارایی ندارد</a:t>
             </a:r>
-            <a:endParaRPr lang="en-US" sz="1400" dirty="0"/>
+            <a:endParaRPr lang="en-US" sz="1500" dirty="0"/>
           </a:p>
         </p:txBody>
       </p:sp>
@@ -4298,7 +4453,7 @@
         <p:spPr>
           <a:xfrm>
             <a:off x="457200" y="1234440"/>
-            <a:ext cx="2560320" cy="2606040"/>
+            <a:ext cx="2560320" cy="2743200"/>
           </a:xfrm>
           <a:prstGeom prst="roundRect">
             <a:avLst>
@@ -4324,8 +4479,8 @@
         </p:nvSpPr>
         <p:spPr>
           <a:xfrm>
-            <a:off x="594360" y="1344168"/>
-            <a:ext cx="2286000" cy="411480"/>
+            <a:off x="594360" y="1325880"/>
+            <a:ext cx="2286000" cy="640080"/>
           </a:xfrm>
           <a:prstGeom prst="rect">
             <a:avLst/>
@@ -4341,14 +4496,17 @@
               <a:buNone/>
             </a:pPr>
             <a:r>
-              <a:rPr lang="en-US" sz="1600" b="1" dirty="0">
+              <a:rPr lang="en-US" sz="1700" b="1" dirty="0">
                 <a:solidFill>
                   <a:schemeClr val="tx2"/>
                 </a:solidFill>
+                <a:latin typeface="B Nazanin" pitchFamily="34" charset="0"/>
+                <a:ea typeface="B Nazanin" pitchFamily="34" charset="-122"/>
+                <a:cs typeface="B Nazanin" pitchFamily="34" charset="-120"/>
               </a:rPr>
               <a:t>مشکلات در کشورهای در حال توسعه</a:t>
             </a:r>
-            <a:endParaRPr lang="en-US" sz="1600" dirty="0"/>
+            <a:endParaRPr lang="en-US" sz="1700" dirty="0"/>
           </a:p>
         </p:txBody>
       </p:sp>
@@ -4360,8 +4518,8 @@
         </p:nvSpPr>
         <p:spPr>
           <a:xfrm>
-            <a:off x="594360" y="1801368"/>
-            <a:ext cx="2286000" cy="1920240"/>
+            <a:off x="594360" y="2011680"/>
+            <a:ext cx="2286000" cy="1874520"/>
           </a:xfrm>
           <a:prstGeom prst="rect">
             <a:avLst/>
@@ -4381,14 +4539,17 @@
               <a:buChar char="•"/>
             </a:pPr>
             <a:r>
-              <a:rPr lang="en-US" sz="1400" dirty="0">
+              <a:rPr lang="en-US" sz="1500" dirty="0">
                 <a:solidFill>
                   <a:schemeClr val="tx1"/>
                 </a:solidFill>
+                <a:latin typeface="B Nazanin" pitchFamily="34" charset="0"/>
+                <a:ea typeface="B Nazanin" pitchFamily="34" charset="-122"/>
+                <a:cs typeface="B Nazanin" pitchFamily="34" charset="-120"/>
               </a:rPr>
               <a:t>نادیده گرفتن روابط غیررسمی و خانوادگی</a:t>
             </a:r>
-            <a:endParaRPr lang="en-US" sz="1400" dirty="0"/>
+            <a:endParaRPr lang="en-US" sz="1500" dirty="0"/>
           </a:p>
           <a:p>
             <a:pPr algn="r" marL="342900" indent="-342900">
@@ -4399,14 +4560,17 @@
               <a:buChar char="•"/>
             </a:pPr>
             <a:r>
-              <a:rPr lang="en-US" sz="1400" dirty="0">
+              <a:rPr lang="en-US" sz="1500" dirty="0">
                 <a:solidFill>
                   <a:schemeClr val="tx1"/>
                 </a:solidFill>
+                <a:latin typeface="B Nazanin" pitchFamily="34" charset="0"/>
+                <a:ea typeface="B Nazanin" pitchFamily="34" charset="-122"/>
+                <a:cs typeface="B Nazanin" pitchFamily="34" charset="-120"/>
               </a:rPr>
               <a:t>عدم تطابق با ساختارهای سیاسی سنتی</a:t>
             </a:r>
-            <a:endParaRPr lang="en-US" sz="1400" dirty="0"/>
+            <a:endParaRPr lang="en-US" sz="1500" dirty="0"/>
           </a:p>
           <a:p>
             <a:pPr algn="r" marL="342900" indent="-342900">
@@ -4417,14 +4581,17 @@
               <a:buChar char="•"/>
             </a:pPr>
             <a:r>
-              <a:rPr lang="en-US" sz="1400" dirty="0">
+              <a:rPr lang="en-US" sz="1500" dirty="0">
                 <a:solidFill>
                   <a:schemeClr val="tx1"/>
                 </a:solidFill>
+                <a:latin typeface="B Nazanin" pitchFamily="34" charset="0"/>
+                <a:ea typeface="B Nazanin" pitchFamily="34" charset="-122"/>
+                <a:cs typeface="B Nazanin" pitchFamily="34" charset="-120"/>
               </a:rPr>
               <a:t>شکاف بین انتظارات رسمی و رفتار عملی کارکنان</a:t>
             </a:r>
-            <a:endParaRPr lang="en-US" sz="1400" dirty="0"/>
+            <a:endParaRPr lang="en-US" sz="1500" dirty="0"/>
           </a:p>
         </p:txBody>
       </p:sp>
@@ -4436,12 +4603,12 @@
         </p:nvSpPr>
         <p:spPr>
           <a:xfrm>
-            <a:off x="457200" y="3931920"/>
-            <a:ext cx="8229600" cy="777240"/>
+            <a:off x="457200" y="4069080"/>
+            <a:ext cx="8229600" cy="640080"/>
           </a:xfrm>
           <a:prstGeom prst="roundRect">
             <a:avLst>
-              <a:gd name="adj" fmla="val 11765"/>
+              <a:gd name="adj" fmla="val 14286"/>
             </a:avLst>
           </a:prstGeom>
           <a:solidFill>
@@ -4463,8 +4630,8 @@
         </p:nvSpPr>
         <p:spPr>
           <a:xfrm>
-            <a:off x="640080" y="3931920"/>
-            <a:ext cx="7863840" cy="777240"/>
+            <a:off x="640080" y="4069080"/>
+            <a:ext cx="7863840" cy="640080"/>
           </a:xfrm>
           <a:prstGeom prst="rect">
             <a:avLst/>
@@ -4480,10 +4647,13 @@
               <a:buNone/>
             </a:pPr>
             <a:r>
-              <a:rPr lang="en-US" sz="1400" dirty="0">
+              <a:rPr lang="en-US" sz="1600" dirty="0">
                 <a:solidFill>
                   <a:schemeClr val="tx1"/>
                 </a:solidFill>
+                <a:latin typeface="B Nazanin" pitchFamily="34" charset="0"/>
+                <a:ea typeface="B Nazanin" pitchFamily="34" charset="-122"/>
+                <a:cs typeface="B Nazanin" pitchFamily="34" charset="-120"/>
               </a:rPr>
               <a:t>💡 </a:t>
             </a:r>
@@ -4491,14 +4661,17 @@
               <a:buNone/>
             </a:pPr>
             <a:r>
-              <a:rPr lang="en-US" sz="1400" dirty="0">
+              <a:rPr lang="en-US" sz="1600" dirty="0">
                 <a:solidFill>
                   <a:schemeClr val="tx1"/>
                 </a:solidFill>
+                <a:latin typeface="B Nazanin" pitchFamily="34" charset="0"/>
+                <a:ea typeface="B Nazanin" pitchFamily="34" charset="-122"/>
+                <a:cs typeface="B Nazanin" pitchFamily="34" charset="-120"/>
               </a:rPr>
               <a:t>«آلوریان» معتقد است مدل وبری در کشورهای در حال توسعه باعث «بوروکراسی زائد» می‌شود.</a:t>
             </a:r>
-            <a:endParaRPr lang="en-US" sz="1400" dirty="0"/>
+            <a:endParaRPr lang="en-US" sz="1600" dirty="0"/>
           </a:p>
         </p:txBody>
       </p:sp>
@@ -4599,14 +4772,17 @@
               <a:buNone/>
             </a:pPr>
             <a:r>
-              <a:rPr lang="en-US" sz="3200" b="1" dirty="0">
+              <a:rPr lang="en-US" sz="3400" dirty="0">
                 <a:solidFill>
                   <a:schemeClr val="accent1"/>
                 </a:solidFill>
+                <a:latin typeface="B Titr" pitchFamily="34" charset="0"/>
+                <a:ea typeface="B Titr" pitchFamily="34" charset="-122"/>
+                <a:cs typeface="B Titr" pitchFamily="34" charset="-120"/>
               </a:rPr>
               <a:t>مدل‌های سه‌گانه بوروکراسی در نظریه ریگز</a:t>
             </a:r>
-            <a:endParaRPr lang="en-US" sz="3200" dirty="0"/>
+            <a:endParaRPr lang="en-US" sz="3400" dirty="0"/>
           </a:p>
         </p:txBody>
       </p:sp>
@@ -4647,14 +4823,14 @@
                         <a:buNone/>
                       </a:pPr>
                       <a:r>
-                        <a:rPr lang="en-US" sz="1400" b="1" dirty="0">
+                        <a:rPr lang="en-US" sz="1600" b="1" dirty="0">
                           <a:solidFill>
                             <a:schemeClr val="bg1"/>
                           </a:solidFill>
                         </a:rPr>
                         <a:t>مثال</a:t>
                       </a:r>
-                      <a:endParaRPr lang="en-US" sz="1400" dirty="0"/>
+                      <a:endParaRPr lang="en-US" sz="1600" dirty="0"/>
                     </a:p>
                   </a:txBody>
                   <a:tcPr marL="91440" marR="91440" marT="45720" marB="45720" anchor="ctr">
@@ -4708,14 +4884,14 @@
                         <a:buNone/>
                       </a:pPr>
                       <a:r>
-                        <a:rPr lang="en-US" sz="1400" b="1" dirty="0">
+                        <a:rPr lang="en-US" sz="1600" b="1" dirty="0">
                           <a:solidFill>
                             <a:schemeClr val="bg1"/>
                           </a:solidFill>
                         </a:rPr>
                         <a:t>ویژگی‌ها</a:t>
                       </a:r>
-                      <a:endParaRPr lang="en-US" sz="1400" dirty="0"/>
+                      <a:endParaRPr lang="en-US" sz="1600" dirty="0"/>
                     </a:p>
                   </a:txBody>
                   <a:tcPr marL="91440" marR="91440" marT="45720" marB="45720" anchor="ctr">
@@ -4769,14 +4945,14 @@
                         <a:buNone/>
                       </a:pPr>
                       <a:r>
-                        <a:rPr lang="en-US" sz="1400" b="1" dirty="0">
+                        <a:rPr lang="en-US" sz="1600" b="1" dirty="0">
                           <a:solidFill>
                             <a:schemeClr val="bg1"/>
                           </a:solidFill>
                         </a:rPr>
                         <a:t>مدل</a:t>
                       </a:r>
-                      <a:endParaRPr lang="en-US" sz="1400" dirty="0"/>
+                      <a:endParaRPr lang="en-US" sz="1600" dirty="0"/>
                     </a:p>
                   </a:txBody>
                   <a:tcPr marL="91440" marR="91440" marT="45720" marB="45720" anchor="ctr">
@@ -4832,14 +5008,14 @@
                         <a:buNone/>
                       </a:pPr>
                       <a:r>
-                        <a:rPr lang="en-US" sz="1400" dirty="0">
+                        <a:rPr lang="en-US" sz="1600" dirty="0">
                           <a:solidFill>
                             <a:schemeClr val="tx1"/>
                           </a:solidFill>
                         </a:rPr>
                         <a:t>کشورهای توسعه‌یافته غربی</a:t>
                       </a:r>
-                      <a:endParaRPr lang="en-US" sz="1400" dirty="0"/>
+                      <a:endParaRPr lang="en-US" sz="1600" dirty="0"/>
                     </a:p>
                   </a:txBody>
                   <a:tcPr marL="91440" marR="91440" marT="45720" marB="45720" anchor="ctr">
@@ -4893,14 +5069,14 @@
                         <a:buNone/>
                       </a:pPr>
                       <a:r>
-                        <a:rPr lang="en-US" sz="1400" dirty="0">
+                        <a:rPr lang="en-US" sz="1600" dirty="0">
                           <a:solidFill>
                             <a:schemeClr val="tx1"/>
                           </a:solidFill>
                         </a:rPr>
                         <a:t>قوانین، عقلانیت، سلسله‌مراتب، تخصص</a:t>
                       </a:r>
-                      <a:endParaRPr lang="en-US" sz="1400" dirty="0"/>
+                      <a:endParaRPr lang="en-US" sz="1600" dirty="0"/>
                     </a:p>
                   </a:txBody>
                   <a:tcPr marL="91440" marR="91440" marT="45720" marB="45720" anchor="ctr">
@@ -4954,14 +5130,14 @@
                         <a:buNone/>
                       </a:pPr>
                       <a:r>
-                        <a:rPr lang="en-US" sz="1400" dirty="0">
+                        <a:rPr lang="en-US" sz="1600" dirty="0">
                           <a:solidFill>
                             <a:schemeClr val="tx1"/>
                           </a:solidFill>
                         </a:rPr>
                         <a:t>۱. مدل «حاکمیت» (Weberian/Classic)</a:t>
                       </a:r>
-                      <a:endParaRPr lang="en-US" sz="1400" dirty="0"/>
+                      <a:endParaRPr lang="en-US" sz="1600" dirty="0"/>
                     </a:p>
                   </a:txBody>
                   <a:tcPr marL="91440" marR="91440" marT="45720" marB="45720" anchor="ctr">
@@ -5017,14 +5193,14 @@
                         <a:buNone/>
                       </a:pPr>
                       <a:r>
-                        <a:rPr lang="en-US" sz="1400" dirty="0">
+                        <a:rPr lang="en-US" sz="1600" dirty="0">
                           <a:solidFill>
                             <a:schemeClr val="tx1"/>
                           </a:solidFill>
                         </a:rPr>
                         <a:t>کشورهای در حال توسعه (ایران، مصر)</a:t>
                       </a:r>
-                      <a:endParaRPr lang="en-US" sz="1400" dirty="0"/>
+                      <a:endParaRPr lang="en-US" sz="1600" dirty="0"/>
                     </a:p>
                   </a:txBody>
                   <a:tcPr marL="91440" marR="91440" marT="45720" marB="45720" anchor="ctr">
@@ -5078,14 +5254,14 @@
                         <a:buNone/>
                       </a:pPr>
                       <a:r>
-                        <a:rPr lang="en-US" sz="1400" dirty="0">
+                        <a:rPr lang="en-US" sz="1600" dirty="0">
                           <a:solidFill>
                             <a:schemeClr val="tx1"/>
                           </a:solidFill>
                         </a:rPr>
                         <a:t>ترکیب سنتی و مدرن، عدم تطابق کارکردها با ساختار</a:t>
                       </a:r>
-                      <a:endParaRPr lang="en-US" sz="1400" dirty="0"/>
+                      <a:endParaRPr lang="en-US" sz="1600" dirty="0"/>
                     </a:p>
                   </a:txBody>
                   <a:tcPr marL="91440" marR="91440" marT="45720" marB="45720" anchor="ctr">
@@ -5139,14 +5315,14 @@
                         <a:buNone/>
                       </a:pPr>
                       <a:r>
-                        <a:rPr lang="en-US" sz="1400" dirty="0">
+                        <a:rPr lang="en-US" sz="1600" dirty="0">
                           <a:solidFill>
                             <a:schemeClr val="tx1"/>
                           </a:solidFill>
                         </a:rPr>
                         <a:t>۲. مدل «منشوری» (Prismatic)</a:t>
                       </a:r>
-                      <a:endParaRPr lang="en-US" sz="1400" dirty="0"/>
+                      <a:endParaRPr lang="en-US" sz="1600" dirty="0"/>
                     </a:p>
                   </a:txBody>
                   <a:tcPr marL="91440" marR="91440" marT="45720" marB="45720" anchor="ctr">
@@ -5202,14 +5378,14 @@
                         <a:buNone/>
                       </a:pPr>
                       <a:r>
-                        <a:rPr lang="en-US" sz="1400" dirty="0">
+                        <a:rPr lang="en-US" sz="1600" dirty="0">
                           <a:solidFill>
                             <a:schemeClr val="tx1"/>
                           </a:solidFill>
                         </a:rPr>
                         <a:t>—</a:t>
                       </a:r>
-                      <a:endParaRPr lang="en-US" sz="1400" dirty="0"/>
+                      <a:endParaRPr lang="en-US" sz="1600" dirty="0"/>
                     </a:p>
                   </a:txBody>
                   <a:tcPr marL="91440" marR="91440" marT="45720" marB="45720" anchor="ctr">
@@ -5263,14 +5439,14 @@
                         <a:buNone/>
                       </a:pPr>
                       <a:r>
-                        <a:rPr lang="en-US" sz="1400" dirty="0">
+                        <a:rPr lang="en-US" sz="1600" dirty="0">
                           <a:solidFill>
                             <a:schemeClr val="tx1"/>
                           </a:solidFill>
                         </a:rPr>
                         <a:t>ترکیبی؛ شامل «دیوان»، «اتاق» و «اداره»</a:t>
                       </a:r>
-                      <a:endParaRPr lang="en-US" sz="1400" dirty="0"/>
+                      <a:endParaRPr lang="en-US" sz="1600" dirty="0"/>
                     </a:p>
                   </a:txBody>
                   <a:tcPr marL="91440" marR="91440" marT="45720" marB="45720" anchor="ctr">
@@ -5324,14 +5500,14 @@
                         <a:buNone/>
                       </a:pPr>
                       <a:r>
-                        <a:rPr lang="en-US" sz="1400" dirty="0">
+                        <a:rPr lang="en-US" sz="1600" dirty="0">
                           <a:solidFill>
                             <a:schemeClr val="tx1"/>
                           </a:solidFill>
                         </a:rPr>
                         <a:t>۳. مدل «سالا» (Sala)</a:t>
                       </a:r>
-                      <a:endParaRPr lang="en-US" sz="1400" dirty="0"/>
+                      <a:endParaRPr lang="en-US" sz="1600" dirty="0"/>
                     </a:p>
                   </a:txBody>
                   <a:tcPr marL="91440" marR="91440" marT="45720" marB="45720" anchor="ctr">
@@ -5389,12 +5565,12 @@
         </p:nvSpPr>
         <p:spPr>
           <a:xfrm>
-            <a:off x="457200" y="3931920"/>
-            <a:ext cx="8229600" cy="777240"/>
+            <a:off x="457200" y="4069080"/>
+            <a:ext cx="8229600" cy="640080"/>
           </a:xfrm>
           <a:prstGeom prst="roundRect">
             <a:avLst>
-              <a:gd name="adj" fmla="val 11765"/>
+              <a:gd name="adj" fmla="val 14286"/>
             </a:avLst>
           </a:prstGeom>
           <a:solidFill>
@@ -5416,8 +5592,8 @@
         </p:nvSpPr>
         <p:spPr>
           <a:xfrm>
-            <a:off x="640080" y="3931920"/>
-            <a:ext cx="7863840" cy="777240"/>
+            <a:off x="640080" y="4069080"/>
+            <a:ext cx="7863840" cy="640080"/>
           </a:xfrm>
           <a:prstGeom prst="rect">
             <a:avLst/>
@@ -5433,10 +5609,13 @@
               <a:buNone/>
             </a:pPr>
             <a:r>
-              <a:rPr lang="en-US" sz="1400" dirty="0">
+              <a:rPr lang="en-US" sz="1600" dirty="0">
                 <a:solidFill>
                   <a:schemeClr val="tx1"/>
                 </a:solidFill>
+                <a:latin typeface="B Nazanin" pitchFamily="34" charset="0"/>
+                <a:ea typeface="B Nazanin" pitchFamily="34" charset="-122"/>
+                <a:cs typeface="B Nazanin" pitchFamily="34" charset="-120"/>
               </a:rPr>
               <a:t>💡 </a:t>
             </a:r>
@@ -5444,14 +5623,17 @@
               <a:buNone/>
             </a:pPr>
             <a:r>
-              <a:rPr lang="en-US" sz="1400" dirty="0">
+              <a:rPr lang="en-US" sz="1600" dirty="0">
                 <a:solidFill>
                   <a:schemeClr val="tx1"/>
                 </a:solidFill>
+                <a:latin typeface="B Nazanin" pitchFamily="34" charset="0"/>
+                <a:ea typeface="B Nazanin" pitchFamily="34" charset="-122"/>
+                <a:cs typeface="B Nazanin" pitchFamily="34" charset="-120"/>
               </a:rPr>
               <a:t>در مدل «منشوری»، پدیده «هم‌ریختگی» (Overlapping) رخ می‌دهد؛ سازمان‌های جدید جایگزین قدیمی‌ها نمی‌شوند، بلکه در کنار آنها با کارکردهای متناقض ادامه می‌یابند.</a:t>
             </a:r>
-            <a:endParaRPr lang="en-US" sz="1400" dirty="0"/>
+            <a:endParaRPr lang="en-US" sz="1600" dirty="0"/>
           </a:p>
         </p:txBody>
       </p:sp>
@@ -5552,14 +5734,17 @@
               <a:buNone/>
             </a:pPr>
             <a:r>
-              <a:rPr lang="en-US" sz="3200" b="1" dirty="0">
+              <a:rPr lang="en-US" sz="3400" dirty="0">
                 <a:solidFill>
                   <a:schemeClr val="accent1"/>
                 </a:solidFill>
+                <a:latin typeface="B Titr" pitchFamily="34" charset="0"/>
+                <a:ea typeface="B Titr" pitchFamily="34" charset="-122"/>
+                <a:cs typeface="B Titr" pitchFamily="34" charset="-120"/>
               </a:rPr>
               <a:t>یکپارچگی و عدم یکپارچگی در جوامع</a:t>
             </a:r>
-            <a:endParaRPr lang="en-US" sz="3200" dirty="0"/>
+            <a:endParaRPr lang="en-US" sz="3400" dirty="0"/>
           </a:p>
         </p:txBody>
       </p:sp>
@@ -5572,7 +5757,7 @@
         <p:spPr>
           <a:xfrm>
             <a:off x="6126480" y="1234440"/>
-            <a:ext cx="2560320" cy="2606040"/>
+            <a:ext cx="2560320" cy="2743200"/>
           </a:xfrm>
           <a:prstGeom prst="roundRect">
             <a:avLst>
@@ -5598,8 +5783,8 @@
         </p:nvSpPr>
         <p:spPr>
           <a:xfrm>
-            <a:off x="6263640" y="1344168"/>
-            <a:ext cx="2286000" cy="411480"/>
+            <a:off x="6263640" y="1325880"/>
+            <a:ext cx="2286000" cy="640080"/>
           </a:xfrm>
           <a:prstGeom prst="rect">
             <a:avLst/>
@@ -5615,14 +5800,17 @@
               <a:buNone/>
             </a:pPr>
             <a:r>
-              <a:rPr lang="en-US" sz="1600" b="1" dirty="0">
+              <a:rPr lang="en-US" sz="1700" b="1" dirty="0">
                 <a:solidFill>
                   <a:schemeClr val="tx2"/>
                 </a:solidFill>
+                <a:latin typeface="B Nazanin" pitchFamily="34" charset="0"/>
+                <a:ea typeface="B Nazanin" pitchFamily="34" charset="-122"/>
+                <a:cs typeface="B Nazanin" pitchFamily="34" charset="-120"/>
               </a:rPr>
               <a:t>جامعه یکپارچه (Fused)</a:t>
             </a:r>
-            <a:endParaRPr lang="en-US" sz="1600" dirty="0"/>
+            <a:endParaRPr lang="en-US" sz="1700" dirty="0"/>
           </a:p>
         </p:txBody>
       </p:sp>
@@ -5634,8 +5822,8 @@
         </p:nvSpPr>
         <p:spPr>
           <a:xfrm>
-            <a:off x="6263640" y="1801368"/>
-            <a:ext cx="2286000" cy="1920240"/>
+            <a:off x="6263640" y="2011680"/>
+            <a:ext cx="2286000" cy="1874520"/>
           </a:xfrm>
           <a:prstGeom prst="rect">
             <a:avLst/>
@@ -5655,14 +5843,17 @@
               <a:buChar char="•"/>
             </a:pPr>
             <a:r>
-              <a:rPr lang="en-US" sz="1400" dirty="0">
+              <a:rPr lang="en-US" sz="1500" dirty="0">
                 <a:solidFill>
                   <a:schemeClr val="tx1"/>
                 </a:solidFill>
+                <a:latin typeface="B Nazanin" pitchFamily="34" charset="0"/>
+                <a:ea typeface="B Nazanin" pitchFamily="34" charset="-122"/>
+                <a:cs typeface="B Nazanin" pitchFamily="34" charset="-120"/>
               </a:rPr>
               <a:t>جوامع سنتی</a:t>
             </a:r>
-            <a:endParaRPr lang="en-US" sz="1400" dirty="0"/>
+            <a:endParaRPr lang="en-US" sz="1500" dirty="0"/>
           </a:p>
           <a:p>
             <a:pPr algn="r" marL="342900" indent="-342900">
@@ -5673,14 +5864,17 @@
               <a:buChar char="•"/>
             </a:pPr>
             <a:r>
-              <a:rPr lang="en-US" sz="1400" dirty="0">
+              <a:rPr lang="en-US" sz="1500" dirty="0">
                 <a:solidFill>
                   <a:schemeClr val="tx1"/>
                 </a:solidFill>
+                <a:latin typeface="B Nazanin" pitchFamily="34" charset="0"/>
+                <a:ea typeface="B Nazanin" pitchFamily="34" charset="-122"/>
+                <a:cs typeface="B Nazanin" pitchFamily="34" charset="-120"/>
               </a:rPr>
               <a:t>ساختارها و کارکردها تفکیک نشده‌اند (قبیله‌ای)</a:t>
             </a:r>
-            <a:endParaRPr lang="en-US" sz="1400" dirty="0"/>
+            <a:endParaRPr lang="en-US" sz="1500" dirty="0"/>
           </a:p>
         </p:txBody>
       </p:sp>
@@ -5693,7 +5887,7 @@
         <p:spPr>
           <a:xfrm>
             <a:off x="3291840" y="1234440"/>
-            <a:ext cx="2560320" cy="2606040"/>
+            <a:ext cx="2560320" cy="2743200"/>
           </a:xfrm>
           <a:prstGeom prst="roundRect">
             <a:avLst>
@@ -5719,8 +5913,8 @@
         </p:nvSpPr>
         <p:spPr>
           <a:xfrm>
-            <a:off x="3429000" y="1344168"/>
-            <a:ext cx="2286000" cy="411480"/>
+            <a:off x="3429000" y="1325880"/>
+            <a:ext cx="2286000" cy="640080"/>
           </a:xfrm>
           <a:prstGeom prst="rect">
             <a:avLst/>
@@ -5736,14 +5930,17 @@
               <a:buNone/>
             </a:pPr>
             <a:r>
-              <a:rPr lang="en-US" sz="1600" b="1" dirty="0">
+              <a:rPr lang="en-US" sz="1700" b="1" dirty="0">
                 <a:solidFill>
                   <a:schemeClr val="tx2"/>
                 </a:solidFill>
+                <a:latin typeface="B Nazanin" pitchFamily="34" charset="0"/>
+                <a:ea typeface="B Nazanin" pitchFamily="34" charset="-122"/>
+                <a:cs typeface="B Nazanin" pitchFamily="34" charset="-120"/>
               </a:rPr>
               <a:t>جامعه منشوری (Prismatic)</a:t>
             </a:r>
-            <a:endParaRPr lang="en-US" sz="1600" dirty="0"/>
+            <a:endParaRPr lang="en-US" sz="1700" dirty="0"/>
           </a:p>
         </p:txBody>
       </p:sp>
@@ -5755,8 +5952,8 @@
         </p:nvSpPr>
         <p:spPr>
           <a:xfrm>
-            <a:off x="3429000" y="1801368"/>
-            <a:ext cx="2286000" cy="1920240"/>
+            <a:off x="3429000" y="2011680"/>
+            <a:ext cx="2286000" cy="1874520"/>
           </a:xfrm>
           <a:prstGeom prst="rect">
             <a:avLst/>
@@ -5776,14 +5973,17 @@
               <a:buChar char="•"/>
             </a:pPr>
             <a:r>
-              <a:rPr lang="en-US" sz="1400" dirty="0">
+              <a:rPr lang="en-US" sz="1500" dirty="0">
                 <a:solidFill>
                   <a:schemeClr val="tx1"/>
                 </a:solidFill>
+                <a:latin typeface="B Nazanin" pitchFamily="34" charset="0"/>
+                <a:ea typeface="B Nazanin" pitchFamily="34" charset="-122"/>
+                <a:cs typeface="B Nazanin" pitchFamily="34" charset="-120"/>
               </a:rPr>
               <a:t>جوامع در حال گذار</a:t>
             </a:r>
-            <a:endParaRPr lang="en-US" sz="1400" dirty="0"/>
+            <a:endParaRPr lang="en-US" sz="1500" dirty="0"/>
           </a:p>
           <a:p>
             <a:pPr algn="r" marL="342900" indent="-342900">
@@ -5794,14 +5994,17 @@
               <a:buChar char="•"/>
             </a:pPr>
             <a:r>
-              <a:rPr lang="en-US" sz="1400" dirty="0">
+              <a:rPr lang="en-US" sz="1500" dirty="0">
                 <a:solidFill>
                   <a:schemeClr val="tx1"/>
                 </a:solidFill>
+                <a:latin typeface="B Nazanin" pitchFamily="34" charset="0"/>
+                <a:ea typeface="B Nazanin" pitchFamily="34" charset="-122"/>
+                <a:cs typeface="B Nazanin" pitchFamily="34" charset="-120"/>
               </a:rPr>
               <a:t>نهادهای جدید ایجاد شده، اما کارکردها هنوز سنتی است</a:t>
             </a:r>
-            <a:endParaRPr lang="en-US" sz="1400" dirty="0"/>
+            <a:endParaRPr lang="en-US" sz="1500" dirty="0"/>
           </a:p>
         </p:txBody>
       </p:sp>
@@ -5814,7 +6017,7 @@
         <p:spPr>
           <a:xfrm>
             <a:off x="457200" y="1234440"/>
-            <a:ext cx="2560320" cy="2606040"/>
+            <a:ext cx="2560320" cy="2743200"/>
           </a:xfrm>
           <a:prstGeom prst="roundRect">
             <a:avLst>
@@ -5840,8 +6043,8 @@
         </p:nvSpPr>
         <p:spPr>
           <a:xfrm>
-            <a:off x="594360" y="1344168"/>
-            <a:ext cx="2286000" cy="411480"/>
+            <a:off x="594360" y="1325880"/>
+            <a:ext cx="2286000" cy="640080"/>
           </a:xfrm>
           <a:prstGeom prst="rect">
             <a:avLst/>
@@ -5857,14 +6060,17 @@
               <a:buNone/>
             </a:pPr>
             <a:r>
-              <a:rPr lang="en-US" sz="1600" b="1" dirty="0">
+              <a:rPr lang="en-US" sz="1700" b="1" dirty="0">
                 <a:solidFill>
                   <a:schemeClr val="tx2"/>
                 </a:solidFill>
+                <a:latin typeface="B Nazanin" pitchFamily="34" charset="0"/>
+                <a:ea typeface="B Nazanin" pitchFamily="34" charset="-122"/>
+                <a:cs typeface="B Nazanin" pitchFamily="34" charset="-120"/>
               </a:rPr>
               <a:t>جامعه تفکیک‌یافته (Diffracted)</a:t>
             </a:r>
-            <a:endParaRPr lang="en-US" sz="1600" dirty="0"/>
+            <a:endParaRPr lang="en-US" sz="1700" dirty="0"/>
           </a:p>
         </p:txBody>
       </p:sp>
@@ -5876,8 +6082,8 @@
         </p:nvSpPr>
         <p:spPr>
           <a:xfrm>
-            <a:off x="594360" y="1801368"/>
-            <a:ext cx="2286000" cy="1920240"/>
+            <a:off x="594360" y="2011680"/>
+            <a:ext cx="2286000" cy="1874520"/>
           </a:xfrm>
           <a:prstGeom prst="rect">
             <a:avLst/>
@@ -5897,14 +6103,17 @@
               <a:buChar char="•"/>
             </a:pPr>
             <a:r>
-              <a:rPr lang="en-US" sz="1400" dirty="0">
+              <a:rPr lang="en-US" sz="1500" dirty="0">
                 <a:solidFill>
                   <a:schemeClr val="tx1"/>
                 </a:solidFill>
+                <a:latin typeface="B Nazanin" pitchFamily="34" charset="0"/>
+                <a:ea typeface="B Nazanin" pitchFamily="34" charset="-122"/>
+                <a:cs typeface="B Nazanin" pitchFamily="34" charset="-120"/>
               </a:rPr>
               <a:t>جوامع مدرن</a:t>
             </a:r>
-            <a:endParaRPr lang="en-US" sz="1400" dirty="0"/>
+            <a:endParaRPr lang="en-US" sz="1500" dirty="0"/>
           </a:p>
           <a:p>
             <a:pPr algn="r" marL="342900" indent="-342900">
@@ -5915,14 +6124,17 @@
               <a:buChar char="•"/>
             </a:pPr>
             <a:r>
-              <a:rPr lang="en-US" sz="1400" dirty="0">
+              <a:rPr lang="en-US" sz="1500" dirty="0">
                 <a:solidFill>
                   <a:schemeClr val="tx1"/>
                 </a:solidFill>
+                <a:latin typeface="B Nazanin" pitchFamily="34" charset="0"/>
+                <a:ea typeface="B Nazanin" pitchFamily="34" charset="-122"/>
+                <a:cs typeface="B Nazanin" pitchFamily="34" charset="-120"/>
               </a:rPr>
               <a:t>تفکیک کامل ساختارها و کارکردها</a:t>
             </a:r>
-            <a:endParaRPr lang="en-US" sz="1400" dirty="0"/>
+            <a:endParaRPr lang="en-US" sz="1500" dirty="0"/>
           </a:p>
         </p:txBody>
       </p:sp>
@@ -5934,12 +6146,12 @@
         </p:nvSpPr>
         <p:spPr>
           <a:xfrm>
-            <a:off x="457200" y="3931920"/>
-            <a:ext cx="8229600" cy="777240"/>
+            <a:off x="457200" y="4069080"/>
+            <a:ext cx="8229600" cy="640080"/>
           </a:xfrm>
           <a:prstGeom prst="roundRect">
             <a:avLst>
-              <a:gd name="adj" fmla="val 11765"/>
+              <a:gd name="adj" fmla="val 14286"/>
             </a:avLst>
           </a:prstGeom>
           <a:solidFill>
@@ -5961,8 +6173,8 @@
         </p:nvSpPr>
         <p:spPr>
           <a:xfrm>
-            <a:off x="640080" y="3931920"/>
-            <a:ext cx="7863840" cy="777240"/>
+            <a:off x="640080" y="4069080"/>
+            <a:ext cx="7863840" cy="640080"/>
           </a:xfrm>
           <a:prstGeom prst="rect">
             <a:avLst/>
@@ -5978,10 +6190,13 @@
               <a:buNone/>
             </a:pPr>
             <a:r>
-              <a:rPr lang="en-US" sz="1400" dirty="0">
+              <a:rPr lang="en-US" sz="1600" dirty="0">
                 <a:solidFill>
                   <a:schemeClr val="tx1"/>
                 </a:solidFill>
+                <a:latin typeface="B Nazanin" pitchFamily="34" charset="0"/>
+                <a:ea typeface="B Nazanin" pitchFamily="34" charset="-122"/>
+                <a:cs typeface="B Nazanin" pitchFamily="34" charset="-120"/>
               </a:rPr>
               <a:t>💡 </a:t>
             </a:r>
@@ -5989,14 +6204,17 @@
               <a:buNone/>
             </a:pPr>
             <a:r>
-              <a:rPr lang="en-US" sz="1400" dirty="0">
+              <a:rPr lang="en-US" sz="1600" dirty="0">
                 <a:solidFill>
                   <a:schemeClr val="tx1"/>
                 </a:solidFill>
+                <a:latin typeface="B Nazanin" pitchFamily="34" charset="0"/>
+                <a:ea typeface="B Nazanin" pitchFamily="34" charset="-122"/>
+                <a:cs typeface="B Nazanin" pitchFamily="34" charset="-120"/>
               </a:rPr>
               <a:t>مثال از متن: ریگز جامعه منشوری را به «ارکستر سمفونی» تشبیه می‌کند که هر نوازنده ساز خود را می‌زند و هماهنگی وجود ندارد.</a:t>
             </a:r>
-            <a:endParaRPr lang="en-US" sz="1400" dirty="0"/>
+            <a:endParaRPr lang="en-US" sz="1600" dirty="0"/>
           </a:p>
         </p:txBody>
       </p:sp>
@@ -6097,14 +6315,17 @@
               <a:buNone/>
             </a:pPr>
             <a:r>
-              <a:rPr lang="en-US" sz="3200" b="1" dirty="0">
+              <a:rPr lang="en-US" sz="3400" dirty="0">
                 <a:solidFill>
                   <a:schemeClr val="accent1"/>
                 </a:solidFill>
+                <a:latin typeface="B Titr" pitchFamily="34" charset="0"/>
+                <a:ea typeface="B Titr" pitchFamily="34" charset="-122"/>
+                <a:cs typeface="B Titr" pitchFamily="34" charset="-120"/>
               </a:rPr>
               <a:t>طبقه‌بندی نظام‌های سیاسی و بوروکراسی</a:t>
             </a:r>
-            <a:endParaRPr lang="en-US" sz="3200" dirty="0"/>
+            <a:endParaRPr lang="en-US" sz="3400" dirty="0"/>
           </a:p>
         </p:txBody>
       </p:sp>
@@ -6117,11 +6338,11 @@
         <p:spPr>
           <a:xfrm>
             <a:off x="4709160" y="1234440"/>
-            <a:ext cx="3977640" cy="2606040"/>
+            <a:ext cx="3977640" cy="2743200"/>
           </a:xfrm>
           <a:prstGeom prst="roundRect">
             <a:avLst>
-              <a:gd name="adj" fmla="val 3509"/>
+              <a:gd name="adj" fmla="val 3333"/>
             </a:avLst>
           </a:prstGeom>
           <a:solidFill>
@@ -6143,8 +6364,8 @@
         </p:nvSpPr>
         <p:spPr>
           <a:xfrm>
-            <a:off x="4846320" y="1344168"/>
-            <a:ext cx="3703320" cy="411480"/>
+            <a:off x="4846320" y="1325880"/>
+            <a:ext cx="3703320" cy="640080"/>
           </a:xfrm>
           <a:prstGeom prst="rect">
             <a:avLst/>
@@ -6160,14 +6381,17 @@
               <a:buNone/>
             </a:pPr>
             <a:r>
-              <a:rPr lang="en-US" sz="1600" b="1" dirty="0">
+              <a:rPr lang="en-US" sz="1700" b="1" dirty="0">
                 <a:solidFill>
                   <a:schemeClr val="tx2"/>
                 </a:solidFill>
+                <a:latin typeface="B Nazanin" pitchFamily="34" charset="0"/>
+                <a:ea typeface="B Nazanin" pitchFamily="34" charset="-122"/>
+                <a:cs typeface="B Nazanin" pitchFamily="34" charset="-120"/>
               </a:rPr>
               <a:t>مدل «حاکمیت» (Heer)</a:t>
             </a:r>
-            <a:endParaRPr lang="en-US" sz="1600" dirty="0"/>
+            <a:endParaRPr lang="en-US" sz="1700" dirty="0"/>
           </a:p>
         </p:txBody>
       </p:sp>
@@ -6179,8 +6403,8 @@
         </p:nvSpPr>
         <p:spPr>
           <a:xfrm>
-            <a:off x="4846320" y="1801368"/>
-            <a:ext cx="3703320" cy="1920240"/>
+            <a:off x="4846320" y="2011680"/>
+            <a:ext cx="3703320" cy="1874520"/>
           </a:xfrm>
           <a:prstGeom prst="rect">
             <a:avLst/>
@@ -6200,14 +6424,17 @@
               <a:buChar char="•"/>
             </a:pPr>
             <a:r>
-              <a:rPr lang="en-US" sz="1400" dirty="0">
+              <a:rPr lang="en-US" sz="1500" dirty="0">
                 <a:solidFill>
                   <a:schemeClr val="tx1"/>
                 </a:solidFill>
+                <a:latin typeface="B Nazanin" pitchFamily="34" charset="0"/>
+                <a:ea typeface="B Nazanin" pitchFamily="34" charset="-122"/>
+                <a:cs typeface="B Nazanin" pitchFamily="34" charset="-120"/>
               </a:rPr>
               <a:t>تقسیم‌بندی نظام‌های سیاسی بر اساس درجه حاکمیت</a:t>
             </a:r>
-            <a:endParaRPr lang="en-US" sz="1400" dirty="0"/>
+            <a:endParaRPr lang="en-US" sz="1500" dirty="0"/>
           </a:p>
         </p:txBody>
       </p:sp>
@@ -6220,11 +6447,11 @@
         <p:spPr>
           <a:xfrm>
             <a:off x="457200" y="1234440"/>
-            <a:ext cx="3977640" cy="2606040"/>
+            <a:ext cx="3977640" cy="2743200"/>
           </a:xfrm>
           <a:prstGeom prst="roundRect">
             <a:avLst>
-              <a:gd name="adj" fmla="val 3509"/>
+              <a:gd name="adj" fmla="val 3333"/>
             </a:avLst>
           </a:prstGeom>
           <a:solidFill>
@@ -6246,8 +6473,8 @@
         </p:nvSpPr>
         <p:spPr>
           <a:xfrm>
-            <a:off x="594360" y="1344168"/>
-            <a:ext cx="3703320" cy="411480"/>
+            <a:off x="594360" y="1325880"/>
+            <a:ext cx="3703320" cy="640080"/>
           </a:xfrm>
           <a:prstGeom prst="rect">
             <a:avLst/>
@@ -6263,14 +6490,17 @@
               <a:buNone/>
             </a:pPr>
             <a:r>
-              <a:rPr lang="en-US" sz="1600" b="1" dirty="0">
+              <a:rPr lang="en-US" sz="1700" b="1" dirty="0">
                 <a:solidFill>
                   <a:schemeClr val="tx2"/>
                 </a:solidFill>
+                <a:latin typeface="B Nazanin" pitchFamily="34" charset="0"/>
+                <a:ea typeface="B Nazanin" pitchFamily="34" charset="-122"/>
+                <a:cs typeface="B Nazanin" pitchFamily="34" charset="-120"/>
               </a:rPr>
               <a:t>انواع حکومت‌ها</a:t>
             </a:r>
-            <a:endParaRPr lang="en-US" sz="1600" dirty="0"/>
+            <a:endParaRPr lang="en-US" sz="1700" dirty="0"/>
           </a:p>
         </p:txBody>
       </p:sp>
@@ -6282,8 +6512,8 @@
         </p:nvSpPr>
         <p:spPr>
           <a:xfrm>
-            <a:off x="594360" y="1801368"/>
-            <a:ext cx="3703320" cy="1920240"/>
+            <a:off x="594360" y="2011680"/>
+            <a:ext cx="3703320" cy="1874520"/>
           </a:xfrm>
           <a:prstGeom prst="rect">
             <a:avLst/>
@@ -6303,14 +6533,17 @@
               <a:buChar char="•"/>
             </a:pPr>
             <a:r>
-              <a:rPr lang="en-US" sz="1400" dirty="0">
+              <a:rPr lang="en-US" sz="1500" dirty="0">
                 <a:solidFill>
                   <a:schemeClr val="tx1"/>
                 </a:solidFill>
+                <a:latin typeface="B Nazanin" pitchFamily="34" charset="0"/>
+                <a:ea typeface="B Nazanin" pitchFamily="34" charset="-122"/>
+                <a:cs typeface="B Nazanin" pitchFamily="34" charset="-120"/>
               </a:rPr>
               <a:t>حکومت حاکم (متمرکز مطلق) ← استبدادی سنتی</a:t>
             </a:r>
-            <a:endParaRPr lang="en-US" sz="1400" dirty="0"/>
+            <a:endParaRPr lang="en-US" sz="1500" dirty="0"/>
           </a:p>
           <a:p>
             <a:pPr algn="r" marL="342900" indent="-342900">
@@ -6321,14 +6554,17 @@
               <a:buChar char="•"/>
             </a:pPr>
             <a:r>
-              <a:rPr lang="en-US" sz="1400" dirty="0">
+              <a:rPr lang="en-US" sz="1500" dirty="0">
                 <a:solidFill>
                   <a:schemeClr val="tx1"/>
                 </a:solidFill>
+                <a:latin typeface="B Nazanin" pitchFamily="34" charset="0"/>
+                <a:ea typeface="B Nazanin" pitchFamily="34" charset="-122"/>
+                <a:cs typeface="B Nazanin" pitchFamily="34" charset="-120"/>
               </a:rPr>
               <a:t>حکومت حزب (تک‌حزبی) ← شوروی سابق، چین</a:t>
             </a:r>
-            <a:endParaRPr lang="en-US" sz="1400" dirty="0"/>
+            <a:endParaRPr lang="en-US" sz="1500" dirty="0"/>
           </a:p>
           <a:p>
             <a:pPr algn="r" marL="342900" indent="-342900">
@@ -6339,14 +6575,17 @@
               <a:buChar char="•"/>
             </a:pPr>
             <a:r>
-              <a:rPr lang="en-US" sz="1400" dirty="0">
+              <a:rPr lang="en-US" sz="1500" dirty="0">
                 <a:solidFill>
                   <a:schemeClr val="tx1"/>
                 </a:solidFill>
+                <a:latin typeface="B Nazanin" pitchFamily="34" charset="0"/>
+                <a:ea typeface="B Nazanin" pitchFamily="34" charset="-122"/>
+                <a:cs typeface="B Nazanin" pitchFamily="34" charset="-120"/>
               </a:rPr>
               <a:t>حکومت بوروکراتیک (دموکراسی) ← کشورهای غربی</a:t>
             </a:r>
-            <a:endParaRPr lang="en-US" sz="1400" dirty="0"/>
+            <a:endParaRPr lang="en-US" sz="1500" dirty="0"/>
           </a:p>
         </p:txBody>
       </p:sp>
@@ -6358,12 +6597,12 @@
         </p:nvSpPr>
         <p:spPr>
           <a:xfrm>
-            <a:off x="457200" y="3931920"/>
-            <a:ext cx="8229600" cy="777240"/>
+            <a:off x="457200" y="4069080"/>
+            <a:ext cx="8229600" cy="640080"/>
           </a:xfrm>
           <a:prstGeom prst="roundRect">
             <a:avLst>
-              <a:gd name="adj" fmla="val 11765"/>
+              <a:gd name="adj" fmla="val 14286"/>
             </a:avLst>
           </a:prstGeom>
           <a:solidFill>
@@ -6385,8 +6624,8 @@
         </p:nvSpPr>
         <p:spPr>
           <a:xfrm>
-            <a:off x="640080" y="3931920"/>
-            <a:ext cx="7863840" cy="777240"/>
+            <a:off x="640080" y="4069080"/>
+            <a:ext cx="7863840" cy="640080"/>
           </a:xfrm>
           <a:prstGeom prst="rect">
             <a:avLst/>
@@ -6402,10 +6641,13 @@
               <a:buNone/>
             </a:pPr>
             <a:r>
-              <a:rPr lang="en-US" sz="1400" dirty="0">
+              <a:rPr lang="en-US" sz="1600" dirty="0">
                 <a:solidFill>
                   <a:schemeClr val="tx1"/>
                 </a:solidFill>
+                <a:latin typeface="B Nazanin" pitchFamily="34" charset="0"/>
+                <a:ea typeface="B Nazanin" pitchFamily="34" charset="-122"/>
+                <a:cs typeface="B Nazanin" pitchFamily="34" charset="-120"/>
               </a:rPr>
               <a:t>💡 </a:t>
             </a:r>
@@ -6413,14 +6655,17 @@
               <a:buNone/>
             </a:pPr>
             <a:r>
-              <a:rPr lang="en-US" sz="1400" dirty="0">
+              <a:rPr lang="en-US" sz="1600" dirty="0">
                 <a:solidFill>
                   <a:schemeClr val="tx1"/>
                 </a:solidFill>
+                <a:latin typeface="B Nazanin" pitchFamily="34" charset="0"/>
+                <a:ea typeface="B Nazanin" pitchFamily="34" charset="-122"/>
+                <a:cs typeface="B Nazanin" pitchFamily="34" charset="-120"/>
               </a:rPr>
               <a:t>در «حکومت حاکم»، قدرت در دست یک فرد یا گروه کوچک متمرکز است و بوروکراسی صرفاً ابزاری برای اجرای دستورات است.</a:t>
             </a:r>
-            <a:endParaRPr lang="en-US" sz="1400" dirty="0"/>
+            <a:endParaRPr lang="en-US" sz="1600" dirty="0"/>
           </a:p>
         </p:txBody>
       </p:sp>
@@ -6521,14 +6766,17 @@
               <a:buNone/>
             </a:pPr>
             <a:r>
-              <a:rPr lang="en-US" sz="3200" b="1" dirty="0">
+              <a:rPr lang="en-US" sz="3400" dirty="0">
                 <a:solidFill>
                   <a:schemeClr val="accent1"/>
                 </a:solidFill>
+                <a:latin typeface="B Titr" pitchFamily="34" charset="0"/>
+                <a:ea typeface="B Titr" pitchFamily="34" charset="-122"/>
+                <a:cs typeface="B Titr" pitchFamily="34" charset="-120"/>
               </a:rPr>
               <a:t>نظریه «گاوس» و بوم‌شناسی اداری</a:t>
             </a:r>
-            <a:endParaRPr lang="en-US" sz="3200" dirty="0"/>
+            <a:endParaRPr lang="en-US" sz="3400" dirty="0"/>
           </a:p>
         </p:txBody>
       </p:sp>
@@ -6541,11 +6789,11 @@
         <p:spPr>
           <a:xfrm>
             <a:off x="4709160" y="1234440"/>
-            <a:ext cx="3977640" cy="2606040"/>
+            <a:ext cx="3977640" cy="2743200"/>
           </a:xfrm>
           <a:prstGeom prst="roundRect">
             <a:avLst>
-              <a:gd name="adj" fmla="val 3509"/>
+              <a:gd name="adj" fmla="val 3333"/>
             </a:avLst>
           </a:prstGeom>
           <a:solidFill>
@@ -6567,8 +6815,8 @@
         </p:nvSpPr>
         <p:spPr>
           <a:xfrm>
-            <a:off x="4846320" y="1344168"/>
-            <a:ext cx="3703320" cy="411480"/>
+            <a:off x="4846320" y="1325880"/>
+            <a:ext cx="3703320" cy="640080"/>
           </a:xfrm>
           <a:prstGeom prst="rect">
             <a:avLst/>
@@ -6584,14 +6832,17 @@
               <a:buNone/>
             </a:pPr>
             <a:r>
-              <a:rPr lang="en-US" sz="1600" b="1" dirty="0">
+              <a:rPr lang="en-US" sz="1700" b="1" dirty="0">
                 <a:solidFill>
                   <a:schemeClr val="tx2"/>
                 </a:solidFill>
+                <a:latin typeface="B Nazanin" pitchFamily="34" charset="0"/>
+                <a:ea typeface="B Nazanin" pitchFamily="34" charset="-122"/>
+                <a:cs typeface="B Nazanin" pitchFamily="34" charset="-120"/>
               </a:rPr>
               <a:t>جان گاوس (John Gaus)</a:t>
             </a:r>
-            <a:endParaRPr lang="en-US" sz="1600" dirty="0"/>
+            <a:endParaRPr lang="en-US" sz="1700" dirty="0"/>
           </a:p>
         </p:txBody>
       </p:sp>
@@ -6603,8 +6854,8 @@
         </p:nvSpPr>
         <p:spPr>
           <a:xfrm>
-            <a:off x="4846320" y="1801368"/>
-            <a:ext cx="3703320" cy="1920240"/>
+            <a:off x="4846320" y="2011680"/>
+            <a:ext cx="3703320" cy="1874520"/>
           </a:xfrm>
           <a:prstGeom prst="rect">
             <a:avLst/>
@@ -6624,14 +6875,17 @@
               <a:buChar char="•"/>
             </a:pPr>
             <a:r>
-              <a:rPr lang="en-US" sz="1400" dirty="0">
+              <a:rPr lang="en-US" sz="1500" dirty="0">
                 <a:solidFill>
                   <a:schemeClr val="tx1"/>
                 </a:solidFill>
+                <a:latin typeface="B Nazanin" pitchFamily="34" charset="0"/>
+                <a:ea typeface="B Nazanin" pitchFamily="34" charset="-122"/>
+                <a:cs typeface="B Nazanin" pitchFamily="34" charset="-120"/>
               </a:rPr>
               <a:t>بنیان‌گذار نظریه بوم‌شناسی اداری</a:t>
             </a:r>
-            <a:endParaRPr lang="en-US" sz="1400" dirty="0"/>
+            <a:endParaRPr lang="en-US" sz="1500" dirty="0"/>
           </a:p>
           <a:p>
             <a:pPr algn="r" marL="342900" indent="-342900">
@@ -6642,14 +6896,17 @@
               <a:buChar char="•"/>
             </a:pPr>
             <a:r>
-              <a:rPr lang="en-US" sz="1400" dirty="0">
+              <a:rPr lang="en-US" sz="1500" dirty="0">
                 <a:solidFill>
                   <a:schemeClr val="tx1"/>
                 </a:solidFill>
+                <a:latin typeface="B Nazanin" pitchFamily="34" charset="0"/>
+                <a:ea typeface="B Nazanin" pitchFamily="34" charset="-122"/>
+                <a:cs typeface="B Nazanin" pitchFamily="34" charset="-120"/>
               </a:rPr>
               <a:t>اداره امور دولتی را نمی‌توان جدا از محیط اجتماعی، اقتصادی و سیاسی مطالعه کرد</a:t>
             </a:r>
-            <a:endParaRPr lang="en-US" sz="1400" dirty="0"/>
+            <a:endParaRPr lang="en-US" sz="1500" dirty="0"/>
           </a:p>
         </p:txBody>
       </p:sp>
@@ -6662,11 +6919,11 @@
         <p:spPr>
           <a:xfrm>
             <a:off x="457200" y="1234440"/>
-            <a:ext cx="3977640" cy="2606040"/>
+            <a:ext cx="3977640" cy="2743200"/>
           </a:xfrm>
           <a:prstGeom prst="roundRect">
             <a:avLst>
-              <a:gd name="adj" fmla="val 3509"/>
+              <a:gd name="adj" fmla="val 3333"/>
             </a:avLst>
           </a:prstGeom>
           <a:solidFill>
@@ -6688,8 +6945,8 @@
         </p:nvSpPr>
         <p:spPr>
           <a:xfrm>
-            <a:off x="594360" y="1344168"/>
-            <a:ext cx="3703320" cy="411480"/>
+            <a:off x="594360" y="1325880"/>
+            <a:ext cx="3703320" cy="640080"/>
           </a:xfrm>
           <a:prstGeom prst="rect">
             <a:avLst/>
@@ -6705,14 +6962,17 @@
               <a:buNone/>
             </a:pPr>
             <a:r>
-              <a:rPr lang="en-US" sz="1600" b="1" dirty="0">
+              <a:rPr lang="en-US" sz="1700" b="1" dirty="0">
                 <a:solidFill>
                   <a:schemeClr val="tx2"/>
                 </a:solidFill>
+                <a:latin typeface="B Nazanin" pitchFamily="34" charset="0"/>
+                <a:ea typeface="B Nazanin" pitchFamily="34" charset="-122"/>
+                <a:cs typeface="B Nazanin" pitchFamily="34" charset="-120"/>
               </a:rPr>
               <a:t>عوامل موثر بر اداره</a:t>
             </a:r>
-            <a:endParaRPr lang="en-US" sz="1600" dirty="0"/>
+            <a:endParaRPr lang="en-US" sz="1700" dirty="0"/>
           </a:p>
         </p:txBody>
       </p:sp>
@@ -6724,8 +6984,8 @@
         </p:nvSpPr>
         <p:spPr>
           <a:xfrm>
-            <a:off x="594360" y="1801368"/>
-            <a:ext cx="3703320" cy="1920240"/>
+            <a:off x="594360" y="2011680"/>
+            <a:ext cx="3703320" cy="1874520"/>
           </a:xfrm>
           <a:prstGeom prst="rect">
             <a:avLst/>
@@ -6745,14 +7005,17 @@
               <a:buChar char="•"/>
             </a:pPr>
             <a:r>
-              <a:rPr lang="en-US" sz="1400" dirty="0">
+              <a:rPr lang="en-US" sz="1500" dirty="0">
                 <a:solidFill>
                   <a:schemeClr val="tx1"/>
                 </a:solidFill>
+                <a:latin typeface="B Nazanin" pitchFamily="34" charset="0"/>
+                <a:ea typeface="B Nazanin" pitchFamily="34" charset="-122"/>
+                <a:cs typeface="B Nazanin" pitchFamily="34" charset="-120"/>
               </a:rPr>
               <a:t>تکنولوژی</a:t>
             </a:r>
-            <a:endParaRPr lang="en-US" sz="1400" dirty="0"/>
+            <a:endParaRPr lang="en-US" sz="1500" dirty="0"/>
           </a:p>
           <a:p>
             <a:pPr algn="r" marL="342900" indent="-342900">
@@ -6763,14 +7026,17 @@
               <a:buChar char="•"/>
             </a:pPr>
             <a:r>
-              <a:rPr lang="en-US" sz="1400" dirty="0">
+              <a:rPr lang="en-US" sz="1500" dirty="0">
                 <a:solidFill>
                   <a:schemeClr val="tx1"/>
                 </a:solidFill>
+                <a:latin typeface="B Nazanin" pitchFamily="34" charset="0"/>
+                <a:ea typeface="B Nazanin" pitchFamily="34" charset="-122"/>
+                <a:cs typeface="B Nazanin" pitchFamily="34" charset="-120"/>
               </a:rPr>
               <a:t>افراد</a:t>
             </a:r>
-            <a:endParaRPr lang="en-US" sz="1400" dirty="0"/>
+            <a:endParaRPr lang="en-US" sz="1500" dirty="0"/>
           </a:p>
           <a:p>
             <a:pPr algn="r" marL="342900" indent="-342900">
@@ -6781,14 +7047,17 @@
               <a:buChar char="•"/>
             </a:pPr>
             <a:r>
-              <a:rPr lang="en-US" sz="1400" dirty="0">
+              <a:rPr lang="en-US" sz="1500" dirty="0">
                 <a:solidFill>
                   <a:schemeClr val="tx1"/>
                 </a:solidFill>
+                <a:latin typeface="B Nazanin" pitchFamily="34" charset="0"/>
+                <a:ea typeface="B Nazanin" pitchFamily="34" charset="-122"/>
+                <a:cs typeface="B Nazanin" pitchFamily="34" charset="-120"/>
               </a:rPr>
               <a:t>مکان</a:t>
             </a:r>
-            <a:endParaRPr lang="en-US" sz="1400" dirty="0"/>
+            <a:endParaRPr lang="en-US" sz="1500" dirty="0"/>
           </a:p>
           <a:p>
             <a:pPr algn="r" marL="342900" indent="-342900">
@@ -6799,14 +7068,17 @@
               <a:buChar char="•"/>
             </a:pPr>
             <a:r>
-              <a:rPr lang="en-US" sz="1400" dirty="0">
+              <a:rPr lang="en-US" sz="1500" dirty="0">
                 <a:solidFill>
                   <a:schemeClr val="tx1"/>
                 </a:solidFill>
+                <a:latin typeface="B Nazanin" pitchFamily="34" charset="0"/>
+                <a:ea typeface="B Nazanin" pitchFamily="34" charset="-122"/>
+                <a:cs typeface="B Nazanin" pitchFamily="34" charset="-120"/>
               </a:rPr>
               <a:t>آرزوها و عقاید</a:t>
             </a:r>
-            <a:endParaRPr lang="en-US" sz="1400" dirty="0"/>
+            <a:endParaRPr lang="en-US" sz="1500" dirty="0"/>
           </a:p>
         </p:txBody>
       </p:sp>
@@ -6818,12 +7090,12 @@
         </p:nvSpPr>
         <p:spPr>
           <a:xfrm>
-            <a:off x="457200" y="3931920"/>
-            <a:ext cx="8229600" cy="777240"/>
+            <a:off x="457200" y="4069080"/>
+            <a:ext cx="8229600" cy="640080"/>
           </a:xfrm>
           <a:prstGeom prst="roundRect">
             <a:avLst>
-              <a:gd name="adj" fmla="val 11765"/>
+              <a:gd name="adj" fmla="val 14286"/>
             </a:avLst>
           </a:prstGeom>
           <a:solidFill>
@@ -6845,8 +7117,8 @@
         </p:nvSpPr>
         <p:spPr>
           <a:xfrm>
-            <a:off x="640080" y="3931920"/>
-            <a:ext cx="7863840" cy="777240"/>
+            <a:off x="640080" y="4069080"/>
+            <a:ext cx="7863840" cy="640080"/>
           </a:xfrm>
           <a:prstGeom prst="rect">
             <a:avLst/>
@@ -6862,10 +7134,13 @@
               <a:buNone/>
             </a:pPr>
             <a:r>
-              <a:rPr lang="en-US" sz="1400" dirty="0">
+              <a:rPr lang="en-US" sz="1600" dirty="0">
                 <a:solidFill>
                   <a:schemeClr val="tx1"/>
                 </a:solidFill>
+                <a:latin typeface="B Nazanin" pitchFamily="34" charset="0"/>
+                <a:ea typeface="B Nazanin" pitchFamily="34" charset="-122"/>
+                <a:cs typeface="B Nazanin" pitchFamily="34" charset="-120"/>
               </a:rPr>
               <a:t>💡 </a:t>
             </a:r>
@@ -6873,14 +7148,17 @@
               <a:buNone/>
             </a:pPr>
             <a:r>
-              <a:rPr lang="en-US" sz="1400" dirty="0">
+              <a:rPr lang="en-US" sz="1600" dirty="0">
                 <a:solidFill>
                   <a:schemeClr val="tx1"/>
                 </a:solidFill>
+                <a:latin typeface="B Nazanin" pitchFamily="34" charset="0"/>
+                <a:ea typeface="B Nazanin" pitchFamily="34" charset="-122"/>
+                <a:cs typeface="B Nazanin" pitchFamily="34" charset="-120"/>
               </a:rPr>
               <a:t>«بوم‌شناسی» کمک می‌کند بفهمیم چرا یک مدل اداری در یک کشور موفق و در کشور دیگر ناموفق است. این نظریه بعدها توسط «ریگز» بسط داده شد.</a:t>
             </a:r>
-            <a:endParaRPr lang="en-US" sz="1400" dirty="0"/>
+            <a:endParaRPr lang="en-US" sz="1600" dirty="0"/>
           </a:p>
         </p:txBody>
       </p:sp>
@@ -6981,14 +7259,17 @@
               <a:buNone/>
             </a:pPr>
             <a:r>
-              <a:rPr lang="en-US" sz="3200" b="1" dirty="0">
+              <a:rPr lang="en-US" sz="3400" dirty="0">
                 <a:solidFill>
                   <a:schemeClr val="accent1"/>
                 </a:solidFill>
+                <a:latin typeface="B Titr" pitchFamily="34" charset="0"/>
+                <a:ea typeface="B Titr" pitchFamily="34" charset="-122"/>
+                <a:cs typeface="B Titr" pitchFamily="34" charset="-120"/>
               </a:rPr>
               <a:t>کارمندان دولتی و اندازه دولت</a:t>
             </a:r>
-            <a:endParaRPr lang="en-US" sz="3200" dirty="0"/>
+            <a:endParaRPr lang="en-US" sz="3400" dirty="0"/>
           </a:p>
         </p:txBody>
       </p:sp>
@@ -7001,11 +7282,11 @@
         <p:spPr>
           <a:xfrm>
             <a:off x="457200" y="1234440"/>
-            <a:ext cx="8229600" cy="2606040"/>
+            <a:ext cx="8229600" cy="2743200"/>
           </a:xfrm>
           <a:prstGeom prst="roundRect">
             <a:avLst>
-              <a:gd name="adj" fmla="val 3509"/>
+              <a:gd name="adj" fmla="val 3333"/>
             </a:avLst>
           </a:prstGeom>
           <a:solidFill>
@@ -7027,8 +7308,8 @@
         </p:nvSpPr>
         <p:spPr>
           <a:xfrm>
-            <a:off x="594360" y="1344168"/>
-            <a:ext cx="7955280" cy="411480"/>
+            <a:off x="594360" y="1325880"/>
+            <a:ext cx="7955280" cy="640080"/>
           </a:xfrm>
           <a:prstGeom prst="rect">
             <a:avLst/>
@@ -7044,14 +7325,17 @@
               <a:buNone/>
             </a:pPr>
             <a:r>
-              <a:rPr lang="en-US" sz="1600" b="1" dirty="0">
+              <a:rPr lang="en-US" sz="1700" b="1" dirty="0">
                 <a:solidFill>
                   <a:schemeClr val="tx2"/>
                 </a:solidFill>
+                <a:latin typeface="B Nazanin" pitchFamily="34" charset="0"/>
+                <a:ea typeface="B Nazanin" pitchFamily="34" charset="-122"/>
+                <a:cs typeface="B Nazanin" pitchFamily="34" charset="-120"/>
               </a:rPr>
               <a:t>آمارهای جهانی (جدول ۱ و ۲)</a:t>
             </a:r>
-            <a:endParaRPr lang="en-US" sz="1600" dirty="0"/>
+            <a:endParaRPr lang="en-US" sz="1700" dirty="0"/>
           </a:p>
         </p:txBody>
       </p:sp>
@@ -7063,8 +7347,8 @@
         </p:nvSpPr>
         <p:spPr>
           <a:xfrm>
-            <a:off x="594360" y="1801368"/>
-            <a:ext cx="7955280" cy="1920240"/>
+            <a:off x="594360" y="2011680"/>
+            <a:ext cx="7955280" cy="1874520"/>
           </a:xfrm>
           <a:prstGeom prst="rect">
             <a:avLst/>
@@ -7084,14 +7368,17 @@
               <a:buChar char="•"/>
             </a:pPr>
             <a:r>
-              <a:rPr lang="en-US" sz="1400" dirty="0">
+              <a:rPr lang="en-US" sz="1500" dirty="0">
                 <a:solidFill>
                   <a:schemeClr val="tx1"/>
                 </a:solidFill>
+                <a:latin typeface="B Nazanin" pitchFamily="34" charset="0"/>
+                <a:ea typeface="B Nazanin" pitchFamily="34" charset="-122"/>
+                <a:cs typeface="B Nazanin" pitchFamily="34" charset="-120"/>
               </a:rPr>
               <a:t>کشورهای توسعه‌یافته (سوئد، دانمارک): ۲۵-۳۰٪ استخدام دولتی</a:t>
             </a:r>
-            <a:endParaRPr lang="en-US" sz="1400" dirty="0"/>
+            <a:endParaRPr lang="en-US" sz="1500" dirty="0"/>
           </a:p>
           <a:p>
             <a:pPr algn="r" marL="342900" indent="-342900">
@@ -7102,14 +7389,17 @@
               <a:buChar char="•"/>
             </a:pPr>
             <a:r>
-              <a:rPr lang="en-US" sz="1400" dirty="0">
+              <a:rPr lang="en-US" sz="1500" dirty="0">
                 <a:solidFill>
                   <a:schemeClr val="tx1"/>
                 </a:solidFill>
+                <a:latin typeface="B Nazanin" pitchFamily="34" charset="0"/>
+                <a:ea typeface="B Nazanin" pitchFamily="34" charset="-122"/>
+                <a:cs typeface="B Nazanin" pitchFamily="34" charset="-120"/>
               </a:rPr>
               <a:t>کشورهای در حال توسعه (هند، مصر): سهم کمتر، اما لزوماً کارایی بیشتر نیست</a:t>
             </a:r>
-            <a:endParaRPr lang="en-US" sz="1400" dirty="0"/>
+            <a:endParaRPr lang="en-US" sz="1500" dirty="0"/>
           </a:p>
         </p:txBody>
       </p:sp>
@@ -7121,12 +7411,12 @@
         </p:nvSpPr>
         <p:spPr>
           <a:xfrm>
-            <a:off x="457200" y="3931920"/>
-            <a:ext cx="8229600" cy="777240"/>
+            <a:off x="457200" y="4069080"/>
+            <a:ext cx="8229600" cy="640080"/>
           </a:xfrm>
           <a:prstGeom prst="roundRect">
             <a:avLst>
-              <a:gd name="adj" fmla="val 11765"/>
+              <a:gd name="adj" fmla="val 14286"/>
             </a:avLst>
           </a:prstGeom>
           <a:solidFill>
@@ -7148,8 +7438,8 @@
         </p:nvSpPr>
         <p:spPr>
           <a:xfrm>
-            <a:off x="640080" y="3931920"/>
-            <a:ext cx="7863840" cy="777240"/>
+            <a:off x="640080" y="4069080"/>
+            <a:ext cx="7863840" cy="640080"/>
           </a:xfrm>
           <a:prstGeom prst="rect">
             <a:avLst/>
@@ -7165,10 +7455,13 @@
               <a:buNone/>
             </a:pPr>
             <a:r>
-              <a:rPr lang="en-US" sz="1400" dirty="0">
+              <a:rPr lang="en-US" sz="1600" dirty="0">
                 <a:solidFill>
                   <a:schemeClr val="tx1"/>
                 </a:solidFill>
+                <a:latin typeface="B Nazanin" pitchFamily="34" charset="0"/>
+                <a:ea typeface="B Nazanin" pitchFamily="34" charset="-122"/>
+                <a:cs typeface="B Nazanin" pitchFamily="34" charset="-120"/>
               </a:rPr>
               <a:t>💡 </a:t>
             </a:r>
@@ -7176,14 +7469,17 @@
               <a:buNone/>
             </a:pPr>
             <a:r>
-              <a:rPr lang="en-US" sz="1400" dirty="0">
+              <a:rPr lang="en-US" sz="1600" dirty="0">
                 <a:solidFill>
                   <a:schemeClr val="tx1"/>
                 </a:solidFill>
+                <a:latin typeface="B Nazanin" pitchFamily="34" charset="0"/>
+                <a:ea typeface="B Nazanin" pitchFamily="34" charset="-122"/>
+                <a:cs typeface="B Nazanin" pitchFamily="34" charset="-120"/>
               </a:rPr>
               <a:t>در بسیاری از کشورهای در حال توسعه، «بزرگ شدن دولت» = افزایش بوروکراسی زائد، نه افزایش خدمات. این پدیده به «قانون پارکینسون» معروف است: کار کارمندان تا پر شدن زمان موجود گسترش می‌یابد.</a:t>
             </a:r>
-            <a:endParaRPr lang="en-US" sz="1400" dirty="0"/>
+            <a:endParaRPr lang="en-US" sz="1600" dirty="0"/>
           </a:p>
         </p:txBody>
       </p:sp>
@@ -7284,14 +7580,17 @@
               <a:buNone/>
             </a:pPr>
             <a:r>
-              <a:rPr lang="en-US" sz="3200" b="1" dirty="0">
+              <a:rPr lang="en-US" sz="3400" dirty="0">
                 <a:solidFill>
                   <a:schemeClr val="accent1"/>
                 </a:solidFill>
+                <a:latin typeface="B Titr" pitchFamily="34" charset="0"/>
+                <a:ea typeface="B Titr" pitchFamily="34" charset="-122"/>
+                <a:cs typeface="B Titr" pitchFamily="34" charset="-120"/>
               </a:rPr>
               <a:t>مدل‌های نظام اداری در کشورهای در حال توسعه</a:t>
             </a:r>
-            <a:endParaRPr lang="en-US" sz="3200" dirty="0"/>
+            <a:endParaRPr lang="en-US" sz="3400" dirty="0"/>
           </a:p>
         </p:txBody>
       </p:sp>
@@ -7372,14 +7671,17 @@
               <a:buNone/>
             </a:pPr>
             <a:r>
-              <a:rPr lang="en-US" sz="1600" b="1" dirty="0">
+              <a:rPr lang="en-US" sz="1800" b="1" dirty="0">
                 <a:solidFill>
                   <a:schemeClr val="bg1"/>
                 </a:solidFill>
+                <a:latin typeface="B Nazanin" pitchFamily="34" charset="0"/>
+                <a:ea typeface="B Nazanin" pitchFamily="34" charset="-122"/>
+                <a:cs typeface="B Nazanin" pitchFamily="34" charset="-120"/>
               </a:rPr>
               <a:t>۱</a:t>
             </a:r>
-            <a:endParaRPr lang="en-US" sz="1600" dirty="0"/>
+            <a:endParaRPr lang="en-US" sz="1800" dirty="0"/>
           </a:p>
         </p:txBody>
       </p:sp>
@@ -7408,14 +7710,17 @@
               <a:buNone/>
             </a:pPr>
             <a:r>
-              <a:rPr lang="en-US" sz="1600" b="1" dirty="0">
+              <a:rPr lang="en-US" sz="1800" b="1" dirty="0">
                 <a:solidFill>
                   <a:schemeClr val="tx2"/>
                 </a:solidFill>
+                <a:latin typeface="B Nazanin" pitchFamily="34" charset="0"/>
+                <a:ea typeface="B Nazanin" pitchFamily="34" charset="-122"/>
+                <a:cs typeface="B Nazanin" pitchFamily="34" charset="-120"/>
               </a:rPr>
               <a:t>مدل‌های مردم‌محور (Populist)</a:t>
             </a:r>
-            <a:endParaRPr lang="en-US" sz="1600" dirty="0"/>
+            <a:endParaRPr lang="en-US" sz="1800" dirty="0"/>
           </a:p>
         </p:txBody>
       </p:sp>
@@ -7444,14 +7749,17 @@
               <a:buNone/>
             </a:pPr>
             <a:r>
-              <a:rPr lang="en-US" sz="1400" dirty="0">
+              <a:rPr lang="en-US" sz="1600" dirty="0">
                 <a:solidFill>
                   <a:schemeClr val="tx1"/>
                 </a:solidFill>
+                <a:latin typeface="B Nazanin" pitchFamily="34" charset="0"/>
+                <a:ea typeface="B Nazanin" pitchFamily="34" charset="-122"/>
+                <a:cs typeface="B Nazanin" pitchFamily="34" charset="-120"/>
               </a:rPr>
               <a:t>تأکید بر مشارکت مردمی</a:t>
             </a:r>
-            <a:endParaRPr lang="en-US" sz="1400" dirty="0"/>
+            <a:endParaRPr lang="en-US" sz="1600" dirty="0"/>
           </a:p>
         </p:txBody>
       </p:sp>
@@ -7532,14 +7840,17 @@
               <a:buNone/>
             </a:pPr>
             <a:r>
-              <a:rPr lang="en-US" sz="1600" b="1" dirty="0">
+              <a:rPr lang="en-US" sz="1800" b="1" dirty="0">
                 <a:solidFill>
                   <a:schemeClr val="bg1"/>
                 </a:solidFill>
+                <a:latin typeface="B Nazanin" pitchFamily="34" charset="0"/>
+                <a:ea typeface="B Nazanin" pitchFamily="34" charset="-122"/>
+                <a:cs typeface="B Nazanin" pitchFamily="34" charset="-120"/>
               </a:rPr>
               <a:t>۲</a:t>
             </a:r>
-            <a:endParaRPr lang="en-US" sz="1600" dirty="0"/>
+            <a:endParaRPr lang="en-US" sz="1800" dirty="0"/>
           </a:p>
         </p:txBody>
       </p:sp>
@@ -7568,14 +7879,17 @@
               <a:buNone/>
             </a:pPr>
             <a:r>
-              <a:rPr lang="en-US" sz="1600" b="1" dirty="0">
+              <a:rPr lang="en-US" sz="1800" b="1" dirty="0">
                 <a:solidFill>
                   <a:schemeClr val="tx2"/>
                 </a:solidFill>
+                <a:latin typeface="B Nazanin" pitchFamily="34" charset="0"/>
+                <a:ea typeface="B Nazanin" pitchFamily="34" charset="-122"/>
+                <a:cs typeface="B Nazanin" pitchFamily="34" charset="-120"/>
               </a:rPr>
               <a:t>مدل‌های بوروکراتیک مطلق</a:t>
             </a:r>
-            <a:endParaRPr lang="en-US" sz="1600" dirty="0"/>
+            <a:endParaRPr lang="en-US" sz="1800" dirty="0"/>
           </a:p>
         </p:txBody>
       </p:sp>
@@ -7604,14 +7918,17 @@
               <a:buNone/>
             </a:pPr>
             <a:r>
-              <a:rPr lang="en-US" sz="1400" dirty="0">
+              <a:rPr lang="en-US" sz="1600" dirty="0">
                 <a:solidFill>
                   <a:schemeClr val="tx1"/>
                 </a:solidFill>
+                <a:latin typeface="B Nazanin" pitchFamily="34" charset="0"/>
+                <a:ea typeface="B Nazanin" pitchFamily="34" charset="-122"/>
+                <a:cs typeface="B Nazanin" pitchFamily="34" charset="-120"/>
               </a:rPr>
               <a:t>کنترل شدید و تمرکز</a:t>
             </a:r>
-            <a:endParaRPr lang="en-US" sz="1400" dirty="0"/>
+            <a:endParaRPr lang="en-US" sz="1600" dirty="0"/>
           </a:p>
         </p:txBody>
       </p:sp>
@@ -7692,14 +8009,17 @@
               <a:buNone/>
             </a:pPr>
             <a:r>
-              <a:rPr lang="en-US" sz="1600" b="1" dirty="0">
+              <a:rPr lang="en-US" sz="1800" b="1" dirty="0">
                 <a:solidFill>
                   <a:schemeClr val="bg1"/>
                 </a:solidFill>
+                <a:latin typeface="B Nazanin" pitchFamily="34" charset="0"/>
+                <a:ea typeface="B Nazanin" pitchFamily="34" charset="-122"/>
+                <a:cs typeface="B Nazanin" pitchFamily="34" charset="-120"/>
               </a:rPr>
               <a:t>۳</a:t>
             </a:r>
-            <a:endParaRPr lang="en-US" sz="1600" dirty="0"/>
+            <a:endParaRPr lang="en-US" sz="1800" dirty="0"/>
           </a:p>
         </p:txBody>
       </p:sp>
@@ -7728,14 +8048,17 @@
               <a:buNone/>
             </a:pPr>
             <a:r>
-              <a:rPr lang="en-US" sz="1600" b="1" dirty="0">
+              <a:rPr lang="en-US" sz="1800" b="1" dirty="0">
                 <a:solidFill>
                   <a:schemeClr val="tx2"/>
                 </a:solidFill>
+                <a:latin typeface="B Nazanin" pitchFamily="34" charset="0"/>
+                <a:ea typeface="B Nazanin" pitchFamily="34" charset="-122"/>
+                <a:cs typeface="B Nazanin" pitchFamily="34" charset="-120"/>
               </a:rPr>
               <a:t>مدل‌های ائتلافی</a:t>
             </a:r>
-            <a:endParaRPr lang="en-US" sz="1600" dirty="0"/>
+            <a:endParaRPr lang="en-US" sz="1800" dirty="0"/>
           </a:p>
         </p:txBody>
       </p:sp>
@@ -7764,14 +8087,17 @@
               <a:buNone/>
             </a:pPr>
             <a:r>
-              <a:rPr lang="en-US" sz="1400" dirty="0">
+              <a:rPr lang="en-US" sz="1600" dirty="0">
                 <a:solidFill>
                   <a:schemeClr val="tx1"/>
                 </a:solidFill>
+                <a:latin typeface="B Nazanin" pitchFamily="34" charset="0"/>
+                <a:ea typeface="B Nazanin" pitchFamily="34" charset="-122"/>
+                <a:cs typeface="B Nazanin" pitchFamily="34" charset="-120"/>
               </a:rPr>
               <a:t>ترکیب نیروهای سیاسی مختلف</a:t>
             </a:r>
-            <a:endParaRPr lang="en-US" sz="1400" dirty="0"/>
+            <a:endParaRPr lang="en-US" sz="1600" dirty="0"/>
           </a:p>
         </p:txBody>
       </p:sp>
@@ -7852,14 +8178,17 @@
               <a:buNone/>
             </a:pPr>
             <a:r>
-              <a:rPr lang="en-US" sz="1600" b="1" dirty="0">
+              <a:rPr lang="en-US" sz="1800" b="1" dirty="0">
                 <a:solidFill>
                   <a:schemeClr val="bg1"/>
                 </a:solidFill>
+                <a:latin typeface="B Nazanin" pitchFamily="34" charset="0"/>
+                <a:ea typeface="B Nazanin" pitchFamily="34" charset="-122"/>
+                <a:cs typeface="B Nazanin" pitchFamily="34" charset="-120"/>
               </a:rPr>
               <a:t>۴</a:t>
             </a:r>
-            <a:endParaRPr lang="en-US" sz="1600" dirty="0"/>
+            <a:endParaRPr lang="en-US" sz="1800" dirty="0"/>
           </a:p>
         </p:txBody>
       </p:sp>
@@ -7888,14 +8217,17 @@
               <a:buNone/>
             </a:pPr>
             <a:r>
-              <a:rPr lang="en-US" sz="1600" b="1" dirty="0">
+              <a:rPr lang="en-US" sz="1800" b="1" dirty="0">
                 <a:solidFill>
                   <a:schemeClr val="tx2"/>
                 </a:solidFill>
+                <a:latin typeface="B Nazanin" pitchFamily="34" charset="0"/>
+                <a:ea typeface="B Nazanin" pitchFamily="34" charset="-122"/>
+                <a:cs typeface="B Nazanin" pitchFamily="34" charset="-120"/>
               </a:rPr>
               <a:t>مدل‌های جنبشی</a:t>
             </a:r>
-            <a:endParaRPr lang="en-US" sz="1600" dirty="0"/>
+            <a:endParaRPr lang="en-US" sz="1800" dirty="0"/>
           </a:p>
         </p:txBody>
       </p:sp>
@@ -7924,14 +8256,17 @@
               <a:buNone/>
             </a:pPr>
             <a:r>
-              <a:rPr lang="en-US" sz="1400" dirty="0">
+              <a:rPr lang="en-US" sz="1600" dirty="0">
                 <a:solidFill>
                   <a:schemeClr val="tx1"/>
                 </a:solidFill>
+                <a:latin typeface="B Nazanin" pitchFamily="34" charset="0"/>
+                <a:ea typeface="B Nazanin" pitchFamily="34" charset="-122"/>
+                <a:cs typeface="B Nazanin" pitchFamily="34" charset="-120"/>
               </a:rPr>
               <a:t>مبتنی بر ایدئولوژی و تحرک سیاسی</a:t>
             </a:r>
-            <a:endParaRPr lang="en-US" sz="1400" dirty="0"/>
+            <a:endParaRPr lang="en-US" sz="1600" dirty="0"/>
           </a:p>
         </p:txBody>
       </p:sp>
@@ -7943,12 +8278,12 @@
         </p:nvSpPr>
         <p:spPr>
           <a:xfrm>
-            <a:off x="457200" y="3931920"/>
-            <a:ext cx="8229600" cy="777240"/>
+            <a:off x="457200" y="4069080"/>
+            <a:ext cx="8229600" cy="640080"/>
           </a:xfrm>
           <a:prstGeom prst="roundRect">
             <a:avLst>
-              <a:gd name="adj" fmla="val 11765"/>
+              <a:gd name="adj" fmla="val 14286"/>
             </a:avLst>
           </a:prstGeom>
           <a:solidFill>
@@ -7970,8 +8305,8 @@
         </p:nvSpPr>
         <p:spPr>
           <a:xfrm>
-            <a:off x="640080" y="3931920"/>
-            <a:ext cx="7863840" cy="777240"/>
+            <a:off x="640080" y="4069080"/>
+            <a:ext cx="7863840" cy="640080"/>
           </a:xfrm>
           <a:prstGeom prst="rect">
             <a:avLst/>
@@ -7987,10 +8322,13 @@
               <a:buNone/>
             </a:pPr>
             <a:r>
-              <a:rPr lang="en-US" sz="1400" dirty="0">
+              <a:rPr lang="en-US" sz="1600" dirty="0">
                 <a:solidFill>
                   <a:schemeClr val="tx1"/>
                 </a:solidFill>
+                <a:latin typeface="B Nazanin" pitchFamily="34" charset="0"/>
+                <a:ea typeface="B Nazanin" pitchFamily="34" charset="-122"/>
+                <a:cs typeface="B Nazanin" pitchFamily="34" charset="-120"/>
               </a:rPr>
               <a:t>💡 </a:t>
             </a:r>
@@ -7998,14 +8336,17 @@
               <a:buNone/>
             </a:pPr>
             <a:r>
-              <a:rPr lang="en-US" sz="1400" dirty="0">
+              <a:rPr lang="en-US" sz="1600" dirty="0">
                 <a:solidFill>
                   <a:schemeClr val="tx1"/>
                 </a:solidFill>
+                <a:latin typeface="B Nazanin" pitchFamily="34" charset="0"/>
+                <a:ea typeface="B Nazanin" pitchFamily="34" charset="-122"/>
+                <a:cs typeface="B Nazanin" pitchFamily="34" charset="-120"/>
               </a:rPr>
               <a:t>این مدل‌ها توسط «ادوارد شیلز» و دیگران بسط یافتند.</a:t>
             </a:r>
-            <a:endParaRPr lang="en-US" sz="1400" dirty="0"/>
+            <a:endParaRPr lang="en-US" sz="1600" dirty="0"/>
           </a:p>
         </p:txBody>
       </p:sp>
@@ -8105,7 +8446,7 @@
     </a:clrScheme>
     <a:fontScheme name="Riggs">
       <a:majorFont>
-        <a:latin typeface="Arial"/>
+        <a:latin typeface="B Titr"/>
         <a:ea typeface=""/>
         <a:cs typeface=""/>
         <a:font script="Jpan" typeface="游ゴシック Light"/>
@@ -8157,7 +8498,7 @@
         <a:font script="Tfng" typeface="Ebrima"/>
       </a:majorFont>
       <a:minorFont>
-        <a:latin typeface="Arial"/>
+        <a:latin typeface="B Nazanin"/>
         <a:ea typeface=""/>
         <a:cs typeface=""/>
         <a:font script="Jpan" typeface="游ゴシック"/>

</xml_diff>

<commit_message>
Give Latin words their own runs with Latin font in all slots
Co-Authored-By: Claude Sonnet 5.5 <noreply@anthropic.com>
Claude-Session: https://claude.ai/code/session_01SLUt5mXodhduysLfzMNqCj
</commit_message>
<xml_diff>
--- a/riggs-bureaucracy.pptx
+++ b/riggs-bureaucracy.pptx
@@ -125,13 +125,13 @@
   <p:extLst>
     <p:ext uri="{521415D9-36F7-43E2-AB2F-B90AF26B5E84}">
       <p14:sectionLst xmlns:p14="http://schemas.microsoft.com/office/powerpoint/2010/main">
-        <p14:section name="آغاز" id="{5c2da6e5-3e6e-3747-b09f-fca273e841de}">
+        <p14:section name="آغاز" id="{44e40e80-6098-71ef-4159-e7c19ac225b2}">
           <p14:sldIdLst>
             <p14:sldId id="256"/>
             <p14:sldId id="257"/>
           </p14:sldIdLst>
         </p14:section>
-        <p14:section name="بخش اول: مبانی نظری ریگز و نقد وبر" id="{8b9bb63c-662b-c352-9196-872fba90fc4e}">
+        <p14:section name="بخش اول: مبانی نظری ریگز و نقد وبر" id="{7701ac0f-d6b2-1498-6655-e54f047e12f5}">
           <p14:sldIdLst>
             <p14:sldId id="258"/>
             <p14:sldId id="259"/>
@@ -139,7 +139,7 @@
             <p14:sldId id="261"/>
           </p14:sldIdLst>
         </p14:section>
-        <p14:section name="بخش دوم: جامعه، حکومت و بوم‌شناسی اداری" id="{154ac544-7b9b-7d84-b8e4-4e60174689ac}">
+        <p14:section name="بخش دوم: جامعه، حکومت و بوم‌شناسی اداری" id="{d0d04d16-08a2-0bc4-6089-9a7ea3b62c0f}">
           <p14:sldIdLst>
             <p14:sldId id="262"/>
             <p14:sldId id="263"/>
@@ -148,7 +148,7 @@
             <p14:sldId id="266"/>
           </p14:sldIdLst>
         </p14:section>
-        <p14:section name="بخش سوم: دولت و نظام‌های اداری" id="{b9e55b62-1c2c-0f21-d04d-a3d1fb4d72d8}">
+        <p14:section name="بخش سوم: دولت و نظام‌های اداری" id="{ce5f2adf-649b-ae7b-d60a-c85fa3b778c7}">
           <p14:sldIdLst>
             <p14:sldId id="267"/>
             <p14:sldId id="268"/>
@@ -156,14 +156,14 @@
             <p14:sldId id="270"/>
           </p14:sldIdLst>
         </p14:section>
-        <p14:section name="بخش چهارم: جمع‌بندی و کاربرد در کلاس" id="{a5e8d032-c10a-66a3-f687-9e66b2dde070}">
+        <p14:section name="بخش چهارم: جمع‌بندی و کاربرد در کلاس" id="{8da67456-c62f-c7c8-43d0-2dda580241d8}">
           <p14:sldIdLst>
             <p14:sldId id="271"/>
             <p14:sldId id="272"/>
             <p14:sldId id="273"/>
           </p14:sldIdLst>
         </p14:section>
-        <p14:section name="پایان" id="{51799078-aaa9-f670-db18-4a583f8be3fc}">
+        <p14:section name="پایان" id="{583241dd-513d-4971-f4a2-eedc3f3154f4}">
           <p14:sldIdLst>
             <p14:sldId id="274"/>
           </p14:sldIdLst>
@@ -3687,7 +3687,29 @@
                 <a:ea typeface="Calibri" pitchFamily="34" charset="-122"/>
                 <a:cs typeface="B Zar" pitchFamily="34" charset="-120"/>
               </a:rPr>
-              <a:t>مدل «حاکمیت» (Heer)</a:t>
+              <a:t>مدل «حاکمیت» (</a:t>
+            </a:r>
+            <a:r>
+              <a:rPr lang="fa-IR" sz="1700" b="1" dirty="0">
+                <a:solidFill>
+                  <a:schemeClr val="tx2"/>
+                </a:solidFill>
+                <a:latin typeface="Calibri" pitchFamily="34" charset="0"/>
+                <a:ea typeface="Calibri" pitchFamily="34" charset="-122"/>
+                <a:cs typeface="Calibri"/>
+              </a:rPr>
+              <a:t>Heer</a:t>
+            </a:r>
+            <a:r>
+              <a:rPr lang="fa-IR" sz="1700" b="1" dirty="0">
+                <a:solidFill>
+                  <a:schemeClr val="tx2"/>
+                </a:solidFill>
+                <a:latin typeface="Calibri" pitchFamily="34" charset="0"/>
+                <a:ea typeface="Calibri" pitchFamily="34" charset="-122"/>
+                <a:cs typeface="B Zar" pitchFamily="34" charset="-120"/>
+              </a:rPr>
+              <a:t>)</a:t>
             </a:r>
             <a:endParaRPr lang="fa-IR" sz="1700" dirty="0"/>
           </a:p>
@@ -4379,7 +4401,29 @@
                 <a:ea typeface="Calibri" pitchFamily="34" charset="-122"/>
                 <a:cs typeface="B Zar" pitchFamily="34" charset="-120"/>
               </a:rPr>
-              <a:t>جان گاوس (John Gaus)</a:t>
+              <a:t>جان گاوس (</a:t>
+            </a:r>
+            <a:r>
+              <a:rPr lang="fa-IR" sz="1700" b="1" dirty="0">
+                <a:solidFill>
+                  <a:schemeClr val="tx2"/>
+                </a:solidFill>
+                <a:latin typeface="Calibri" pitchFamily="34" charset="0"/>
+                <a:ea typeface="Calibri" pitchFamily="34" charset="-122"/>
+                <a:cs typeface="Calibri"/>
+              </a:rPr>
+              <a:t>John Gaus</a:t>
+            </a:r>
+            <a:r>
+              <a:rPr lang="fa-IR" sz="1700" b="1" dirty="0">
+                <a:solidFill>
+                  <a:schemeClr val="tx2"/>
+                </a:solidFill>
+                <a:latin typeface="Calibri" pitchFamily="34" charset="0"/>
+                <a:ea typeface="Calibri" pitchFamily="34" charset="-122"/>
+                <a:cs typeface="B Zar" pitchFamily="34" charset="-120"/>
+              </a:rPr>
+              <a:t>)</a:t>
             </a:r>
             <a:endParaRPr lang="fa-IR" sz="1700" dirty="0"/>
           </a:p>
@@ -5872,7 +5916,29 @@
                 <a:ea typeface="Calibri" pitchFamily="34" charset="-122"/>
                 <a:cs typeface="B Zar" pitchFamily="34" charset="-120"/>
               </a:rPr>
-              <a:t>مدل‌های مردم‌محور (Populist)</a:t>
+              <a:t>مدل‌های مردم‌محور (</a:t>
+            </a:r>
+            <a:r>
+              <a:rPr lang="fa-IR" sz="1700" b="1" dirty="0">
+                <a:solidFill>
+                  <a:schemeClr val="tx2"/>
+                </a:solidFill>
+                <a:latin typeface="Calibri" pitchFamily="34" charset="0"/>
+                <a:ea typeface="Calibri" pitchFamily="34" charset="-122"/>
+                <a:cs typeface="Calibri"/>
+              </a:rPr>
+              <a:t>Populist</a:t>
+            </a:r>
+            <a:r>
+              <a:rPr lang="fa-IR" sz="1700" b="1" dirty="0">
+                <a:solidFill>
+                  <a:schemeClr val="tx2"/>
+                </a:solidFill>
+                <a:latin typeface="Calibri" pitchFamily="34" charset="0"/>
+                <a:ea typeface="Calibri" pitchFamily="34" charset="-122"/>
+                <a:cs typeface="B Zar" pitchFamily="34" charset="-120"/>
+              </a:rPr>
+              <a:t>)</a:t>
             </a:r>
             <a:endParaRPr lang="fa-IR" sz="1700" dirty="0"/>
           </a:p>
@@ -10242,7 +10308,29 @@
                 <a:ea typeface="Calibri" pitchFamily="34" charset="-122"/>
                 <a:cs typeface="B Zar" pitchFamily="34" charset="-120"/>
               </a:rPr>
-              <a:t>فرد ریگز (Riggs)</a:t>
+              <a:t>فرد ریگز (</a:t>
+            </a:r>
+            <a:r>
+              <a:rPr lang="fa-IR" sz="1700" b="1" dirty="0">
+                <a:solidFill>
+                  <a:schemeClr val="tx2"/>
+                </a:solidFill>
+                <a:latin typeface="Calibri" pitchFamily="34" charset="0"/>
+                <a:ea typeface="Calibri" pitchFamily="34" charset="-122"/>
+                <a:cs typeface="Calibri"/>
+              </a:rPr>
+              <a:t>Riggs</a:t>
+            </a:r>
+            <a:r>
+              <a:rPr lang="fa-IR" sz="1700" b="1" dirty="0">
+                <a:solidFill>
+                  <a:schemeClr val="tx2"/>
+                </a:solidFill>
+                <a:latin typeface="Calibri" pitchFamily="34" charset="0"/>
+                <a:ea typeface="Calibri" pitchFamily="34" charset="-122"/>
+                <a:cs typeface="B Zar" pitchFamily="34" charset="-120"/>
+              </a:rPr>
+              <a:t>)</a:t>
             </a:r>
             <a:endParaRPr lang="fa-IR" sz="1700" dirty="0"/>
           </a:p>
@@ -10285,7 +10373,29 @@
                 <a:ea typeface="Calibri" pitchFamily="34" charset="-122"/>
                 <a:cs typeface="B Nazanin" pitchFamily="34" charset="-120"/>
               </a:rPr>
-              <a:t>تئوری منشوری (Prismatic Theory)</a:t>
+              <a:t>تئوری منشوری (</a:t>
+            </a:r>
+            <a:r>
+              <a:rPr lang="fa-IR" sz="1600" dirty="0">
+                <a:solidFill>
+                  <a:schemeClr val="tx1"/>
+                </a:solidFill>
+                <a:latin typeface="Calibri" pitchFamily="34" charset="0"/>
+                <a:ea typeface="Calibri" pitchFamily="34" charset="-122"/>
+                <a:cs typeface="Calibri"/>
+              </a:rPr>
+              <a:t>Prismatic Theory</a:t>
+            </a:r>
+            <a:r>
+              <a:rPr lang="fa-IR" sz="1600" dirty="0">
+                <a:solidFill>
+                  <a:schemeClr val="tx1"/>
+                </a:solidFill>
+                <a:latin typeface="Calibri" pitchFamily="34" charset="0"/>
+                <a:ea typeface="Calibri" pitchFamily="34" charset="-122"/>
+                <a:cs typeface="B Nazanin" pitchFamily="34" charset="-120"/>
+              </a:rPr>
+              <a:t>)</a:t>
             </a:r>
             <a:endParaRPr lang="fa-IR" sz="1600" dirty="0"/>
           </a:p>
@@ -10428,7 +10538,29 @@
                 <a:ea typeface="Calibri" pitchFamily="34" charset="-122"/>
                 <a:cs typeface="B Zar" pitchFamily="34" charset="-120"/>
               </a:rPr>
-              <a:t>مفهوم «سالا» (Sala)</a:t>
+              <a:t>مفهوم «سالا» (</a:t>
+            </a:r>
+            <a:r>
+              <a:rPr lang="fa-IR" sz="1700" b="1" dirty="0">
+                <a:solidFill>
+                  <a:schemeClr val="tx2"/>
+                </a:solidFill>
+                <a:latin typeface="Calibri" pitchFamily="34" charset="0"/>
+                <a:ea typeface="Calibri" pitchFamily="34" charset="-122"/>
+                <a:cs typeface="Calibri"/>
+              </a:rPr>
+              <a:t>Sala</a:t>
+            </a:r>
+            <a:r>
+              <a:rPr lang="fa-IR" sz="1700" b="1" dirty="0">
+                <a:solidFill>
+                  <a:schemeClr val="tx2"/>
+                </a:solidFill>
+                <a:latin typeface="Calibri" pitchFamily="34" charset="0"/>
+                <a:ea typeface="Calibri" pitchFamily="34" charset="-122"/>
+                <a:cs typeface="B Zar" pitchFamily="34" charset="-120"/>
+              </a:rPr>
+              <a:t>)</a:t>
             </a:r>
             <a:endParaRPr lang="fa-IR" sz="1700" dirty="0"/>
           </a:p>
@@ -10471,7 +10603,29 @@
                 <a:ea typeface="Calibri" pitchFamily="34" charset="-122"/>
                 <a:cs typeface="B Nazanin" pitchFamily="34" charset="-120"/>
               </a:rPr>
-              <a:t>دیوان (Bureau): هر سه مدل (متمرکز، مرکب، وسیع)</a:t>
+              <a:t>دیوان (</a:t>
+            </a:r>
+            <a:r>
+              <a:rPr lang="fa-IR" sz="1600" dirty="0">
+                <a:solidFill>
+                  <a:schemeClr val="tx1"/>
+                </a:solidFill>
+                <a:latin typeface="Calibri" pitchFamily="34" charset="0"/>
+                <a:ea typeface="Calibri" pitchFamily="34" charset="-122"/>
+                <a:cs typeface="Calibri"/>
+              </a:rPr>
+              <a:t>Bureau</a:t>
+            </a:r>
+            <a:r>
+              <a:rPr lang="fa-IR" sz="1600" dirty="0">
+                <a:solidFill>
+                  <a:schemeClr val="tx1"/>
+                </a:solidFill>
+                <a:latin typeface="Calibri" pitchFamily="34" charset="0"/>
+                <a:ea typeface="Calibri" pitchFamily="34" charset="-122"/>
+                <a:cs typeface="B Nazanin" pitchFamily="34" charset="-120"/>
+              </a:rPr>
+              <a:t>): هر سه مدل (متمرکز، مرکب، وسیع)</a:t>
             </a:r>
             <a:endParaRPr lang="fa-IR" sz="1600" dirty="0"/>
           </a:p>
@@ -10492,7 +10646,29 @@
                 <a:ea typeface="Calibri" pitchFamily="34" charset="-122"/>
                 <a:cs typeface="B Nazanin" pitchFamily="34" charset="-120"/>
               </a:rPr>
-              <a:t>اتاق (Chamber): بوروکراسی مرکب</a:t>
+              <a:t>اتاق (</a:t>
+            </a:r>
+            <a:r>
+              <a:rPr lang="fa-IR" sz="1600" dirty="0">
+                <a:solidFill>
+                  <a:schemeClr val="tx1"/>
+                </a:solidFill>
+                <a:latin typeface="Calibri" pitchFamily="34" charset="0"/>
+                <a:ea typeface="Calibri" pitchFamily="34" charset="-122"/>
+                <a:cs typeface="Calibri"/>
+              </a:rPr>
+              <a:t>Chamber</a:t>
+            </a:r>
+            <a:r>
+              <a:rPr lang="fa-IR" sz="1600" dirty="0">
+                <a:solidFill>
+                  <a:schemeClr val="tx1"/>
+                </a:solidFill>
+                <a:latin typeface="Calibri" pitchFamily="34" charset="0"/>
+                <a:ea typeface="Calibri" pitchFamily="34" charset="-122"/>
+                <a:cs typeface="B Nazanin" pitchFamily="34" charset="-120"/>
+              </a:rPr>
+              <a:t>): بوروکراسی مرکب</a:t>
             </a:r>
             <a:endParaRPr lang="fa-IR" sz="1600" dirty="0"/>
           </a:p>
@@ -10513,7 +10689,29 @@
                 <a:ea typeface="Calibri" pitchFamily="34" charset="-122"/>
                 <a:cs typeface="B Nazanin" pitchFamily="34" charset="-120"/>
               </a:rPr>
-              <a:t>اداره (Office): بوروکراسی وسیع و جدید</a:t>
+              <a:t>اداره (</a:t>
+            </a:r>
+            <a:r>
+              <a:rPr lang="fa-IR" sz="1600" dirty="0">
+                <a:solidFill>
+                  <a:schemeClr val="tx1"/>
+                </a:solidFill>
+                <a:latin typeface="Calibri" pitchFamily="34" charset="0"/>
+                <a:ea typeface="Calibri" pitchFamily="34" charset="-122"/>
+                <a:cs typeface="Calibri"/>
+              </a:rPr>
+              <a:t>Office</a:t>
+            </a:r>
+            <a:r>
+              <a:rPr lang="fa-IR" sz="1600" dirty="0">
+                <a:solidFill>
+                  <a:schemeClr val="tx1"/>
+                </a:solidFill>
+                <a:latin typeface="Calibri" pitchFamily="34" charset="0"/>
+                <a:ea typeface="Calibri" pitchFamily="34" charset="-122"/>
+                <a:cs typeface="B Nazanin" pitchFamily="34" charset="-120"/>
+              </a:rPr>
+              <a:t>): بوروکراسی وسیع و جدید</a:t>
             </a:r>
             <a:endParaRPr lang="fa-IR" sz="1600" dirty="0"/>
           </a:p>
@@ -12167,7 +12365,29 @@
                           <a:ea typeface="Calibri" pitchFamily="34" charset="-122"/>
                           <a:cs typeface="B Nazanin" pitchFamily="34" charset="-120"/>
                         </a:rPr>
-                        <a:t>۱. مدل «حاکمیت» (Weberian/Classic)</a:t>
+                        <a:t>۱. مدل «حاکمیت» (</a:t>
+                      </a:r>
+                      <a:r>
+                        <a:rPr lang="fa-IR" sz="1600" dirty="0">
+                          <a:solidFill>
+                            <a:schemeClr val="tx1"/>
+                          </a:solidFill>
+                          <a:latin typeface="Calibri" pitchFamily="34" charset="0"/>
+                          <a:ea typeface="Calibri" pitchFamily="34" charset="-122"/>
+                          <a:cs typeface="Calibri"/>
+                        </a:rPr>
+                        <a:t>Weberian/Classic</a:t>
+                      </a:r>
+                      <a:r>
+                        <a:rPr lang="fa-IR" sz="1600" dirty="0">
+                          <a:solidFill>
+                            <a:schemeClr val="tx1"/>
+                          </a:solidFill>
+                          <a:latin typeface="Calibri" pitchFamily="34" charset="0"/>
+                          <a:ea typeface="Calibri" pitchFamily="34" charset="-122"/>
+                          <a:cs typeface="B Nazanin" pitchFamily="34" charset="-120"/>
+                        </a:rPr>
+                        <a:t>)</a:t>
                       </a:r>
                       <a:endParaRPr lang="fa-IR" sz="1600" dirty="0">
                         <a:latin typeface="Calibri" charset="0"/>
@@ -12373,7 +12593,29 @@
                           <a:ea typeface="Calibri" pitchFamily="34" charset="-122"/>
                           <a:cs typeface="B Nazanin" pitchFamily="34" charset="-120"/>
                         </a:rPr>
-                        <a:t>۲. مدل «منشوری» (Prismatic)</a:t>
+                        <a:t>۲. مدل «منشوری» (</a:t>
+                      </a:r>
+                      <a:r>
+                        <a:rPr lang="fa-IR" sz="1600" dirty="0">
+                          <a:solidFill>
+                            <a:schemeClr val="tx1"/>
+                          </a:solidFill>
+                          <a:latin typeface="Calibri" pitchFamily="34" charset="0"/>
+                          <a:ea typeface="Calibri" pitchFamily="34" charset="-122"/>
+                          <a:cs typeface="Calibri"/>
+                        </a:rPr>
+                        <a:t>Prismatic</a:t>
+                      </a:r>
+                      <a:r>
+                        <a:rPr lang="fa-IR" sz="1600" dirty="0">
+                          <a:solidFill>
+                            <a:schemeClr val="tx1"/>
+                          </a:solidFill>
+                          <a:latin typeface="Calibri" pitchFamily="34" charset="0"/>
+                          <a:ea typeface="Calibri" pitchFamily="34" charset="-122"/>
+                          <a:cs typeface="B Nazanin" pitchFamily="34" charset="-120"/>
+                        </a:rPr>
+                        <a:t>)</a:t>
                       </a:r>
                       <a:endParaRPr lang="fa-IR" sz="1600" dirty="0">
                         <a:latin typeface="Calibri" charset="0"/>
@@ -12579,7 +12821,29 @@
                           <a:ea typeface="Calibri" pitchFamily="34" charset="-122"/>
                           <a:cs typeface="B Nazanin" pitchFamily="34" charset="-120"/>
                         </a:rPr>
-                        <a:t>۳. مدل «سالا» (Sala)</a:t>
+                        <a:t>۳. مدل «سالا» (</a:t>
+                      </a:r>
+                      <a:r>
+                        <a:rPr lang="fa-IR" sz="1600" dirty="0">
+                          <a:solidFill>
+                            <a:schemeClr val="tx1"/>
+                          </a:solidFill>
+                          <a:latin typeface="Calibri" pitchFamily="34" charset="0"/>
+                          <a:ea typeface="Calibri" pitchFamily="34" charset="-122"/>
+                          <a:cs typeface="Calibri"/>
+                        </a:rPr>
+                        <a:t>Sala</a:t>
+                      </a:r>
+                      <a:r>
+                        <a:rPr lang="fa-IR" sz="1600" dirty="0">
+                          <a:solidFill>
+                            <a:schemeClr val="tx1"/>
+                          </a:solidFill>
+                          <a:latin typeface="Calibri" pitchFamily="34" charset="0"/>
+                          <a:ea typeface="Calibri" pitchFamily="34" charset="-122"/>
+                          <a:cs typeface="B Nazanin" pitchFamily="34" charset="-120"/>
+                        </a:rPr>
+                        <a:t>)</a:t>
                       </a:r>
                       <a:endParaRPr lang="fa-IR" sz="1600" dirty="0">
                         <a:latin typeface="Calibri" charset="0"/>
@@ -12792,7 +13056,29 @@
                 <a:ea typeface="Calibri" pitchFamily="34" charset="-122"/>
                 <a:cs typeface="B Nazanin" pitchFamily="34" charset="-120"/>
               </a:rPr>
-              <a:t>در مدل «منشوری»، پدیده «هم‌ریختگی» (Overlapping) رخ می‌دهد؛ سازمان‌های جدید جایگزین قدیمی‌ها نمی‌شوند، بلکه در کنار آنها با کارکردهای متناقض ادامه می‌یابند.</a:t>
+              <a:t>در مدل «منشوری»، پدیده «هم‌ریختگی» (</a:t>
+            </a:r>
+            <a:r>
+              <a:rPr lang="fa-IR" sz="1500" dirty="0">
+                <a:solidFill>
+                  <a:schemeClr val="tx1"/>
+                </a:solidFill>
+                <a:latin typeface="Calibri" pitchFamily="34" charset="0"/>
+                <a:ea typeface="Calibri" pitchFamily="34" charset="-122"/>
+                <a:cs typeface="Calibri"/>
+              </a:rPr>
+              <a:t>Overlapping</a:t>
+            </a:r>
+            <a:r>
+              <a:rPr lang="fa-IR" sz="1500" dirty="0">
+                <a:solidFill>
+                  <a:schemeClr val="tx1"/>
+                </a:solidFill>
+                <a:latin typeface="Calibri" pitchFamily="34" charset="0"/>
+                <a:ea typeface="Calibri" pitchFamily="34" charset="-122"/>
+                <a:cs typeface="B Nazanin" pitchFamily="34" charset="-120"/>
+              </a:rPr>
+              <a:t>) رخ می‌دهد؛ سازمان‌های جدید جایگزین قدیمی‌ها نمی‌شوند، بلکه در کنار آنها با کارکردهای متناقض ادامه می‌یابند.</a:t>
             </a:r>
             <a:endParaRPr lang="fa-IR" sz="1500" dirty="0"/>
           </a:p>
@@ -13274,7 +13560,29 @@
                 <a:ea typeface="Calibri" pitchFamily="34" charset="-122"/>
                 <a:cs typeface="B Zar" pitchFamily="34" charset="-120"/>
               </a:rPr>
-              <a:t>جامعه یکپارچه (Fused)</a:t>
+              <a:t>جامعه یکپارچه (</a:t>
+            </a:r>
+            <a:r>
+              <a:rPr lang="fa-IR" sz="1500" b="1" dirty="0">
+                <a:solidFill>
+                  <a:schemeClr val="tx2"/>
+                </a:solidFill>
+                <a:latin typeface="Calibri" pitchFamily="34" charset="0"/>
+                <a:ea typeface="Calibri" pitchFamily="34" charset="-122"/>
+                <a:cs typeface="Calibri"/>
+              </a:rPr>
+              <a:t>Fused</a:t>
+            </a:r>
+            <a:r>
+              <a:rPr lang="fa-IR" sz="1500" b="1" dirty="0">
+                <a:solidFill>
+                  <a:schemeClr val="tx2"/>
+                </a:solidFill>
+                <a:latin typeface="Calibri" pitchFamily="34" charset="0"/>
+                <a:ea typeface="Calibri" pitchFamily="34" charset="-122"/>
+                <a:cs typeface="B Zar" pitchFamily="34" charset="-120"/>
+              </a:rPr>
+              <a:t>)</a:t>
             </a:r>
             <a:endParaRPr lang="fa-IR" sz="1500" dirty="0"/>
           </a:p>
@@ -13460,7 +13768,29 @@
                 <a:ea typeface="Calibri" pitchFamily="34" charset="-122"/>
                 <a:cs typeface="B Zar" pitchFamily="34" charset="-120"/>
               </a:rPr>
-              <a:t>جامعه منشوری (Prismatic)</a:t>
+              <a:t>جامعه منشوری (</a:t>
+            </a:r>
+            <a:r>
+              <a:rPr lang="fa-IR" sz="1500" b="1" dirty="0">
+                <a:solidFill>
+                  <a:schemeClr val="tx2"/>
+                </a:solidFill>
+                <a:latin typeface="Calibri" pitchFamily="34" charset="0"/>
+                <a:ea typeface="Calibri" pitchFamily="34" charset="-122"/>
+                <a:cs typeface="Calibri"/>
+              </a:rPr>
+              <a:t>Prismatic</a:t>
+            </a:r>
+            <a:r>
+              <a:rPr lang="fa-IR" sz="1500" b="1" dirty="0">
+                <a:solidFill>
+                  <a:schemeClr val="tx2"/>
+                </a:solidFill>
+                <a:latin typeface="Calibri" pitchFamily="34" charset="0"/>
+                <a:ea typeface="Calibri" pitchFamily="34" charset="-122"/>
+                <a:cs typeface="B Zar" pitchFamily="34" charset="-120"/>
+              </a:rPr>
+              <a:t>)</a:t>
             </a:r>
             <a:endParaRPr lang="fa-IR" sz="1500" dirty="0"/>
           </a:p>
@@ -13646,7 +13976,29 @@
                 <a:ea typeface="Calibri" pitchFamily="34" charset="-122"/>
                 <a:cs typeface="B Zar" pitchFamily="34" charset="-120"/>
               </a:rPr>
-              <a:t>جامعه تفکیک‌یافته (Diffracted)</a:t>
+              <a:t>جامعه تفکیک‌یافته (</a:t>
+            </a:r>
+            <a:r>
+              <a:rPr lang="fa-IR" sz="1500" b="1" dirty="0">
+                <a:solidFill>
+                  <a:schemeClr val="tx2"/>
+                </a:solidFill>
+                <a:latin typeface="Calibri" pitchFamily="34" charset="0"/>
+                <a:ea typeface="Calibri" pitchFamily="34" charset="-122"/>
+                <a:cs typeface="Calibri"/>
+              </a:rPr>
+              <a:t>Diffracted</a:t>
+            </a:r>
+            <a:r>
+              <a:rPr lang="fa-IR" sz="1500" b="1" dirty="0">
+                <a:solidFill>
+                  <a:schemeClr val="tx2"/>
+                </a:solidFill>
+                <a:latin typeface="Calibri" pitchFamily="34" charset="0"/>
+                <a:ea typeface="Calibri" pitchFamily="34" charset="-122"/>
+                <a:cs typeface="B Zar" pitchFamily="34" charset="-120"/>
+              </a:rPr>
+              <a:t>)</a:t>
             </a:r>
             <a:endParaRPr lang="fa-IR" sz="1500" dirty="0"/>
           </a:p>

</xml_diff>